<commit_message>
Digest test send: Smart Fallback to top-5 by TOS and forced Telegram delivery
- /api/digest/preview: with no new matching lots, returns/sends the 5 best lots by TOS
  (filters at any date first, then any lot) with a clear «test digest» header
- «Қазір маған жіберу» delivers to the linked Telegram even if the channel is off and works
  before filters are saved or migration 0007 is applied (default filters)
- Clear toasts: sent / Telegram not linked / bot blocked; fallback note in the preview
- scripts/test-digest-fallback.mjs: temporary user, 5 fallback cards sorted by TOS, no-chat

Co-Authored-By: Claude Opus 5 <noreply@anthropic.com>
</commit_message>
<xml_diff>
--- a/.codex-finalizer/qazaq-tenders-candidate.pptx
+++ b/.codex-finalizer/qazaq-tenders-candidate.pptx
@@ -2,24 +2,24 @@
 <file path=ppt/presentation.xml><?xml version="1.0" encoding="utf-8"?>
 <p:presentation xmlns:p="http://schemas.openxmlformats.org/presentationml/2006/main">
   <p:sldMasterIdLst>
-    <p:sldMasterId xmlns:r="http://schemas.openxmlformats.org/officeDocument/2006/relationships" id="2147483648" r:id="Rba87ecfd036841d6"/>
+    <p:sldMasterId xmlns:r="http://schemas.openxmlformats.org/officeDocument/2006/relationships" id="2147483648" r:id="R8a55cf3fcb3a47e7"/>
   </p:sldMasterIdLst>
   <p:notesMasterIdLst>
-    <p:notesMasterId xmlns:r="http://schemas.openxmlformats.org/officeDocument/2006/relationships" r:id="R1e59e1b8ffa548b5"/>
+    <p:notesMasterId xmlns:r="http://schemas.openxmlformats.org/officeDocument/2006/relationships" r:id="R57664b4c5e3b4f5c"/>
   </p:notesMasterIdLst>
   <p:sldIdLst>
-    <p:sldId xmlns:r="http://schemas.openxmlformats.org/officeDocument/2006/relationships" id="256" r:id="R2c88c7dad527496d"/>
-    <p:sldId xmlns:r="http://schemas.openxmlformats.org/officeDocument/2006/relationships" id="257" r:id="Re6b6015278074998"/>
-    <p:sldId xmlns:r="http://schemas.openxmlformats.org/officeDocument/2006/relationships" id="258" r:id="Rfb2f7c77b13a44bf"/>
-    <p:sldId xmlns:r="http://schemas.openxmlformats.org/officeDocument/2006/relationships" id="259" r:id="Rafe9b18827314852"/>
-    <p:sldId xmlns:r="http://schemas.openxmlformats.org/officeDocument/2006/relationships" id="260" r:id="R10e86072547c4d0b"/>
-    <p:sldId xmlns:r="http://schemas.openxmlformats.org/officeDocument/2006/relationships" id="261" r:id="R246ef61e72e2427e"/>
-    <p:sldId xmlns:r="http://schemas.openxmlformats.org/officeDocument/2006/relationships" id="262" r:id="R85af85294a8d4375"/>
-    <p:sldId xmlns:r="http://schemas.openxmlformats.org/officeDocument/2006/relationships" id="263" r:id="R7804072753db47e5"/>
-    <p:sldId xmlns:r="http://schemas.openxmlformats.org/officeDocument/2006/relationships" id="264" r:id="R361d5f8ba97b4d2b"/>
-    <p:sldId xmlns:r="http://schemas.openxmlformats.org/officeDocument/2006/relationships" id="265" r:id="Rcbf077e44ad6435b"/>
-    <p:sldId xmlns:r="http://schemas.openxmlformats.org/officeDocument/2006/relationships" id="266" r:id="R039697725e394fd7"/>
-    <p:sldId xmlns:r="http://schemas.openxmlformats.org/officeDocument/2006/relationships" id="267" r:id="Re9450760c808418f"/>
+    <p:sldId xmlns:r="http://schemas.openxmlformats.org/officeDocument/2006/relationships" id="256" r:id="R0bc1b3d6fcb44faf"/>
+    <p:sldId xmlns:r="http://schemas.openxmlformats.org/officeDocument/2006/relationships" id="257" r:id="R8a9329f919d74492"/>
+    <p:sldId xmlns:r="http://schemas.openxmlformats.org/officeDocument/2006/relationships" id="258" r:id="R459cb8beff8d452b"/>
+    <p:sldId xmlns:r="http://schemas.openxmlformats.org/officeDocument/2006/relationships" id="259" r:id="Rfe53a39b30474867"/>
+    <p:sldId xmlns:r="http://schemas.openxmlformats.org/officeDocument/2006/relationships" id="260" r:id="R94e76fcc701e4612"/>
+    <p:sldId xmlns:r="http://schemas.openxmlformats.org/officeDocument/2006/relationships" id="261" r:id="Rd2f895ee6b134303"/>
+    <p:sldId xmlns:r="http://schemas.openxmlformats.org/officeDocument/2006/relationships" id="262" r:id="Rccd4bf53de564070"/>
+    <p:sldId xmlns:r="http://schemas.openxmlformats.org/officeDocument/2006/relationships" id="263" r:id="R5b5bb29aac494009"/>
+    <p:sldId xmlns:r="http://schemas.openxmlformats.org/officeDocument/2006/relationships" id="264" r:id="R0af844c28e304b71"/>
+    <p:sldId xmlns:r="http://schemas.openxmlformats.org/officeDocument/2006/relationships" id="265" r:id="R09d4cac2f8de4156"/>
+    <p:sldId xmlns:r="http://schemas.openxmlformats.org/officeDocument/2006/relationships" id="266" r:id="R541ac9813be34471"/>
+    <p:sldId xmlns:r="http://schemas.openxmlformats.org/officeDocument/2006/relationships" id="267" r:id="R89f0e2133e6b45a1"/>
   </p:sldIdLst>
   <p:sldSz cx="12192000" cy="6858000"/>
   <p:notesSz cx="6858000" cy="9144000"/>
@@ -1291,7 +1291,7 @@
   </p:cSld>
   <p:clrMap bg1="lt1" tx1="dk1" bg2="lt2" tx2="dk2" accent1="accent1" accent2="accent2" accent3="accent3" accent4="accent4" accent5="accent5" accent6="accent6" hlink="hlink" folHlink="folHlink"/>
   <p:sldLayoutIdLst>
-    <p:sldLayoutId xmlns:r="http://schemas.openxmlformats.org/officeDocument/2006/relationships" id="2147483649" r:id="R9450605bce4f4279"/>
+    <p:sldLayoutId xmlns:r="http://schemas.openxmlformats.org/officeDocument/2006/relationships" id="2147483649" r:id="R350ade3b830b4b00"/>
   </p:sldLayoutIdLst>
   <p:txStyles>
     <p:titleStyle>
@@ -2009,7 +2009,7 @@
           <p:cNvPr id="6" name="">
             <a:extLst xmlns:a="http://schemas.openxmlformats.org/drawingml/2006/main">
               <a:ext uri="{FF2B5EF4-FFF2-40B4-BE49-F238E27FC236}">
-                <a16:creationId xmlns:a16="http://schemas.microsoft.com/office/drawing/2014/main" id="{AC33D3C0-D87A-4986-91E0-8890F9468475}"/>
+                <a16:creationId xmlns:a16="http://schemas.microsoft.com/office/drawing/2014/main" id="{E272BE81-D887-44C6-B6A4-AA608E6000EF}"/>
               </a:ext>
             </a:extLst>
           </p:cNvPr>
@@ -2089,7 +2089,7 @@
           <p:cNvPr id="2" name="">
             <a:extLst xmlns:a="http://schemas.openxmlformats.org/drawingml/2006/main">
               <a:ext uri="{FF2B5EF4-FFF2-40B4-BE49-F238E27FC236}">
-                <a16:creationId xmlns:a16="http://schemas.microsoft.com/office/drawing/2014/main" id="{E8E12DF5-F38F-4237-8709-E73CBDD6B79F}"/>
+                <a16:creationId xmlns:a16="http://schemas.microsoft.com/office/drawing/2014/main" id="{8AB2FD19-E107-4FB3-8C9A-29125D2D7B11}"/>
               </a:ext>
             </a:extLst>
           </p:cNvPr>
@@ -2146,7 +2146,7 @@
           <p:cNvPr id="3" name="">
             <a:extLst xmlns:a="http://schemas.openxmlformats.org/drawingml/2006/main">
               <a:ext uri="{FF2B5EF4-FFF2-40B4-BE49-F238E27FC236}">
-                <a16:creationId xmlns:a16="http://schemas.microsoft.com/office/drawing/2014/main" id="{69FB95BB-3482-4E7E-82C2-FC1D474DBFE2}"/>
+                <a16:creationId xmlns:a16="http://schemas.microsoft.com/office/drawing/2014/main" id="{4D4F23D8-A0DF-4D46-B045-24CAFF45513F}"/>
               </a:ext>
             </a:extLst>
           </p:cNvPr>
@@ -2203,7 +2203,7 @@
           <p:cNvPr id="4" name="">
             <a:extLst xmlns:a="http://schemas.openxmlformats.org/drawingml/2006/main">
               <a:ext uri="{FF2B5EF4-FFF2-40B4-BE49-F238E27FC236}">
-                <a16:creationId xmlns:a16="http://schemas.microsoft.com/office/drawing/2014/main" id="{8DC661FF-5F37-40D3-ADC9-394206971907}"/>
+                <a16:creationId xmlns:a16="http://schemas.microsoft.com/office/drawing/2014/main" id="{74B162D5-0F67-425A-8AA1-B5F58471AD00}"/>
               </a:ext>
             </a:extLst>
           </p:cNvPr>
@@ -2260,7 +2260,7 @@
           <p:cNvPr id="5" name="">
             <a:extLst xmlns:a="http://schemas.openxmlformats.org/drawingml/2006/main">
               <a:ext uri="{FF2B5EF4-FFF2-40B4-BE49-F238E27FC236}">
-                <a16:creationId xmlns:a16="http://schemas.microsoft.com/office/drawing/2014/main" id="{5DA320C5-9152-4023-928E-561199016F92}"/>
+                <a16:creationId xmlns:a16="http://schemas.microsoft.com/office/drawing/2014/main" id="{72D6BA6F-D916-498C-94B2-C53F778EAA8A}"/>
               </a:ext>
             </a:extLst>
           </p:cNvPr>
@@ -2315,7 +2315,7 @@
     </p:spTree>
     <p:extLst>
       <p:ext uri="{BB962C8B-B14F-4D97-AF65-F5344CB8AC3E}">
-        <p14:creationId xmlns:p14="http://schemas.microsoft.com/office/powerpoint/2010/main" val="128927315"/>
+        <p14:creationId xmlns:p14="http://schemas.microsoft.com/office/powerpoint/2010/main" val="1893658723"/>
       </p:ext>
     </p:extLst>
   </p:cSld>
@@ -2346,7 +2346,7 @@
           <p:cNvPr id="10" name="">
             <a:extLst xmlns:a="http://schemas.openxmlformats.org/drawingml/2006/main">
               <a:ext uri="{FF2B5EF4-FFF2-40B4-BE49-F238E27FC236}">
-                <a16:creationId xmlns:a16="http://schemas.microsoft.com/office/drawing/2014/main" id="{FD46548F-7741-4A86-B11B-A9F10016F20D}"/>
+                <a16:creationId xmlns:a16="http://schemas.microsoft.com/office/drawing/2014/main" id="{EDA2FDA3-7269-4C53-81F3-C910CD08DF3A}"/>
               </a:ext>
             </a:extLst>
           </p:cNvPr>
@@ -2403,7 +2403,7 @@
           <p:cNvPr id="2" name="">
             <a:extLst xmlns:a="http://schemas.openxmlformats.org/drawingml/2006/main">
               <a:ext uri="{FF2B5EF4-FFF2-40B4-BE49-F238E27FC236}">
-                <a16:creationId xmlns:a16="http://schemas.microsoft.com/office/drawing/2014/main" id="{E54B5314-23E3-4E82-9FBF-0914D355745B}"/>
+                <a16:creationId xmlns:a16="http://schemas.microsoft.com/office/drawing/2014/main" id="{8C471513-159A-4ED2-9701-D0EF5932B2FF}"/>
               </a:ext>
             </a:extLst>
           </p:cNvPr>
@@ -2460,7 +2460,7 @@
           <p:cNvPr id="3" name="">
             <a:extLst xmlns:a="http://schemas.openxmlformats.org/drawingml/2006/main">
               <a:ext uri="{FF2B5EF4-FFF2-40B4-BE49-F238E27FC236}">
-                <a16:creationId xmlns:a16="http://schemas.microsoft.com/office/drawing/2014/main" id="{E76D169A-E919-4676-9453-BE32693A5607}"/>
+                <a16:creationId xmlns:a16="http://schemas.microsoft.com/office/drawing/2014/main" id="{A00CC028-F9E2-4AFE-AB5C-5D14A3AFDFA6}"/>
               </a:ext>
             </a:extLst>
           </p:cNvPr>
@@ -2524,7 +2524,7 @@
         </p:xfrm>
         <a:graphic xmlns:a="http://schemas.openxmlformats.org/drawingml/2006/main">
           <a:graphicData uri="http://schemas.openxmlformats.org/drawingml/2006/chart">
-            <c:chart xmlns:r="http://schemas.openxmlformats.org/officeDocument/2006/relationships" xmlns:c="http://schemas.openxmlformats.org/drawingml/2006/chart" r:id="R40b4bb63d4d14a0b"/>
+            <c:chart xmlns:r="http://schemas.openxmlformats.org/officeDocument/2006/relationships" xmlns:c="http://schemas.openxmlformats.org/drawingml/2006/chart" r:id="Rbdebda356f5d4bba"/>
           </a:graphicData>
         </a:graphic>
       </p:graphicFrame>
@@ -2533,7 +2533,7 @@
           <p:cNvPr id="5" name="">
             <a:extLst xmlns:a="http://schemas.openxmlformats.org/drawingml/2006/main">
               <a:ext uri="{FF2B5EF4-FFF2-40B4-BE49-F238E27FC236}">
-                <a16:creationId xmlns:a16="http://schemas.microsoft.com/office/drawing/2014/main" id="{FB4BE47D-B661-45AF-BB92-071D13C241C1}"/>
+                <a16:creationId xmlns:a16="http://schemas.microsoft.com/office/drawing/2014/main" id="{C93BE3CE-DAEC-4604-A3CE-7CC2431ABE2B}"/>
               </a:ext>
             </a:extLst>
           </p:cNvPr>
@@ -2590,7 +2590,7 @@
           <p:cNvPr id="6" name="">
             <a:extLst xmlns:a="http://schemas.openxmlformats.org/drawingml/2006/main">
               <a:ext uri="{FF2B5EF4-FFF2-40B4-BE49-F238E27FC236}">
-                <a16:creationId xmlns:a16="http://schemas.microsoft.com/office/drawing/2014/main" id="{47EFF9FB-E9F3-4635-A034-93E42DF8B86D}"/>
+                <a16:creationId xmlns:a16="http://schemas.microsoft.com/office/drawing/2014/main" id="{293C26DF-1FAE-4B8A-9E5E-439BD16E4EB9}"/>
               </a:ext>
             </a:extLst>
           </p:cNvPr>
@@ -2647,7 +2647,7 @@
           <p:cNvPr id="7" name="">
             <a:extLst xmlns:a="http://schemas.openxmlformats.org/drawingml/2006/main">
               <a:ext uri="{FF2B5EF4-FFF2-40B4-BE49-F238E27FC236}">
-                <a16:creationId xmlns:a16="http://schemas.microsoft.com/office/drawing/2014/main" id="{5509941D-ED83-4946-AE56-8C75370B1877}"/>
+                <a16:creationId xmlns:a16="http://schemas.microsoft.com/office/drawing/2014/main" id="{D14339AC-5AE5-4472-9CFB-9EEAC48934FB}"/>
               </a:ext>
             </a:extLst>
           </p:cNvPr>
@@ -2704,7 +2704,7 @@
           <p:cNvPr id="8" name="">
             <a:extLst xmlns:a="http://schemas.openxmlformats.org/drawingml/2006/main">
               <a:ext uri="{FF2B5EF4-FFF2-40B4-BE49-F238E27FC236}">
-                <a16:creationId xmlns:a16="http://schemas.microsoft.com/office/drawing/2014/main" id="{5EC2AED3-7823-4B9A-8918-FDA64576D178}"/>
+                <a16:creationId xmlns:a16="http://schemas.microsoft.com/office/drawing/2014/main" id="{AEE17943-EB42-484D-BC04-1C65565BDD64}"/>
               </a:ext>
             </a:extLst>
           </p:cNvPr>
@@ -2761,7 +2761,7 @@
           <p:cNvPr id="9" name="">
             <a:extLst xmlns:a="http://schemas.openxmlformats.org/drawingml/2006/main">
               <a:ext uri="{FF2B5EF4-FFF2-40B4-BE49-F238E27FC236}">
-                <a16:creationId xmlns:a16="http://schemas.microsoft.com/office/drawing/2014/main" id="{B3CF89A0-17FB-444E-BCC0-C575C09E7F79}"/>
+                <a16:creationId xmlns:a16="http://schemas.microsoft.com/office/drawing/2014/main" id="{502E3337-18E8-4619-A75C-BF28F1BCD87B}"/>
               </a:ext>
             </a:extLst>
           </p:cNvPr>
@@ -2816,7 +2816,7 @@
     </p:spTree>
     <p:extLst>
       <p:ext uri="{BB962C8B-B14F-4D97-AF65-F5344CB8AC3E}">
-        <p14:creationId xmlns:p14="http://schemas.microsoft.com/office/powerpoint/2010/main" val="1565279324"/>
+        <p14:creationId xmlns:p14="http://schemas.microsoft.com/office/powerpoint/2010/main" val="1849103054"/>
       </p:ext>
     </p:extLst>
   </p:cSld>
@@ -2847,7 +2847,7 @@
           <p:cNvPr id="13" name="">
             <a:extLst xmlns:a="http://schemas.openxmlformats.org/drawingml/2006/main">
               <a:ext uri="{FF2B5EF4-FFF2-40B4-BE49-F238E27FC236}">
-                <a16:creationId xmlns:a16="http://schemas.microsoft.com/office/drawing/2014/main" id="{008401C6-48FD-4F3A-822B-1E348B537719}"/>
+                <a16:creationId xmlns:a16="http://schemas.microsoft.com/office/drawing/2014/main" id="{D7BAD9FC-5BAB-4E75-BDA5-A1D1FB28B30B}"/>
               </a:ext>
             </a:extLst>
           </p:cNvPr>
@@ -2904,7 +2904,7 @@
           <p:cNvPr id="2" name="">
             <a:extLst xmlns:a="http://schemas.openxmlformats.org/drawingml/2006/main">
               <a:ext uri="{FF2B5EF4-FFF2-40B4-BE49-F238E27FC236}">
-                <a16:creationId xmlns:a16="http://schemas.microsoft.com/office/drawing/2014/main" id="{1191650B-4FC9-48CF-9F02-95AB03BA8059}"/>
+                <a16:creationId xmlns:a16="http://schemas.microsoft.com/office/drawing/2014/main" id="{4847EDEB-5AE5-4447-9BBD-605E32389E51}"/>
               </a:ext>
             </a:extLst>
           </p:cNvPr>
@@ -2961,7 +2961,7 @@
           <p:cNvPr id="3" name="">
             <a:extLst xmlns:a="http://schemas.openxmlformats.org/drawingml/2006/main">
               <a:ext uri="{FF2B5EF4-FFF2-40B4-BE49-F238E27FC236}">
-                <a16:creationId xmlns:a16="http://schemas.microsoft.com/office/drawing/2014/main" id="{19ABD8DE-0C92-4FF2-A524-F69318EF3462}"/>
+                <a16:creationId xmlns:a16="http://schemas.microsoft.com/office/drawing/2014/main" id="{6A7B91C6-8192-4178-9192-41C54BA62A49}"/>
               </a:ext>
             </a:extLst>
           </p:cNvPr>
@@ -3018,7 +3018,7 @@
           <p:cNvPr id="4" name="">
             <a:extLst xmlns:a="http://schemas.openxmlformats.org/drawingml/2006/main">
               <a:ext uri="{FF2B5EF4-FFF2-40B4-BE49-F238E27FC236}">
-                <a16:creationId xmlns:a16="http://schemas.microsoft.com/office/drawing/2014/main" id="{843D64D4-636E-43CF-964F-9F5FA9E798DD}"/>
+                <a16:creationId xmlns:a16="http://schemas.microsoft.com/office/drawing/2014/main" id="{35646CC1-7509-4AAE-88AA-E8EFE1EB13CC}"/>
               </a:ext>
             </a:extLst>
           </p:cNvPr>
@@ -3075,7 +3075,7 @@
           <p:cNvPr id="5" name="">
             <a:extLst xmlns:a="http://schemas.openxmlformats.org/drawingml/2006/main">
               <a:ext uri="{FF2B5EF4-FFF2-40B4-BE49-F238E27FC236}">
-                <a16:creationId xmlns:a16="http://schemas.microsoft.com/office/drawing/2014/main" id="{AB5F4436-A717-47DD-B738-D411D0DA1A71}"/>
+                <a16:creationId xmlns:a16="http://schemas.microsoft.com/office/drawing/2014/main" id="{1BB5FC97-62F0-41C2-B909-56DC874A13E4}"/>
               </a:ext>
             </a:extLst>
           </p:cNvPr>
@@ -3132,7 +3132,7 @@
           <p:cNvPr id="6" name="">
             <a:extLst xmlns:a="http://schemas.openxmlformats.org/drawingml/2006/main">
               <a:ext uri="{FF2B5EF4-FFF2-40B4-BE49-F238E27FC236}">
-                <a16:creationId xmlns:a16="http://schemas.microsoft.com/office/drawing/2014/main" id="{1FDD344D-26AB-44B5-B982-8190ED03D4F5}"/>
+                <a16:creationId xmlns:a16="http://schemas.microsoft.com/office/drawing/2014/main" id="{7F619DEC-4A59-4185-917F-AB80B652BEAF}"/>
               </a:ext>
             </a:extLst>
           </p:cNvPr>
@@ -3189,7 +3189,7 @@
           <p:cNvPr id="7" name="">
             <a:extLst xmlns:a="http://schemas.openxmlformats.org/drawingml/2006/main">
               <a:ext uri="{FF2B5EF4-FFF2-40B4-BE49-F238E27FC236}">
-                <a16:creationId xmlns:a16="http://schemas.microsoft.com/office/drawing/2014/main" id="{7C5D47D3-6544-4256-92D0-9F4F5CBBA881}"/>
+                <a16:creationId xmlns:a16="http://schemas.microsoft.com/office/drawing/2014/main" id="{012A6C16-71AC-4CC4-B586-A3DCBF4E25B0}"/>
               </a:ext>
             </a:extLst>
           </p:cNvPr>
@@ -3246,7 +3246,7 @@
           <p:cNvPr id="8" name="">
             <a:extLst xmlns:a="http://schemas.openxmlformats.org/drawingml/2006/main">
               <a:ext uri="{FF2B5EF4-FFF2-40B4-BE49-F238E27FC236}">
-                <a16:creationId xmlns:a16="http://schemas.microsoft.com/office/drawing/2014/main" id="{F9C413E3-BFB1-43E8-ACC6-3D431DC4344A}"/>
+                <a16:creationId xmlns:a16="http://schemas.microsoft.com/office/drawing/2014/main" id="{1F32669E-8D7F-45E5-95EE-BF1024128E99}"/>
               </a:ext>
             </a:extLst>
           </p:cNvPr>
@@ -3303,7 +3303,7 @@
           <p:cNvPr id="9" name="">
             <a:extLst xmlns:a="http://schemas.openxmlformats.org/drawingml/2006/main">
               <a:ext uri="{FF2B5EF4-FFF2-40B4-BE49-F238E27FC236}">
-                <a16:creationId xmlns:a16="http://schemas.microsoft.com/office/drawing/2014/main" id="{A34585A9-B5A7-4B29-98D2-95D727024444}"/>
+                <a16:creationId xmlns:a16="http://schemas.microsoft.com/office/drawing/2014/main" id="{8BD2D62A-4E45-4098-80EA-4CB85A3737AF}"/>
               </a:ext>
             </a:extLst>
           </p:cNvPr>
@@ -3360,7 +3360,7 @@
           <p:cNvPr id="10" name="">
             <a:extLst xmlns:a="http://schemas.openxmlformats.org/drawingml/2006/main">
               <a:ext uri="{FF2B5EF4-FFF2-40B4-BE49-F238E27FC236}">
-                <a16:creationId xmlns:a16="http://schemas.microsoft.com/office/drawing/2014/main" id="{336CCD1F-9D4E-4BAF-BD55-B1CF85F88FD2}"/>
+                <a16:creationId xmlns:a16="http://schemas.microsoft.com/office/drawing/2014/main" id="{FA777ED6-0E8B-4465-9897-B9271B7D4191}"/>
               </a:ext>
             </a:extLst>
           </p:cNvPr>
@@ -3417,7 +3417,7 @@
           <p:cNvPr id="11" name="">
             <a:extLst xmlns:a="http://schemas.openxmlformats.org/drawingml/2006/main">
               <a:ext uri="{FF2B5EF4-FFF2-40B4-BE49-F238E27FC236}">
-                <a16:creationId xmlns:a16="http://schemas.microsoft.com/office/drawing/2014/main" id="{2642AE96-7336-46B5-AAF9-5C945F0993C5}"/>
+                <a16:creationId xmlns:a16="http://schemas.microsoft.com/office/drawing/2014/main" id="{D2705479-30EE-48C2-8056-820D5370002C}"/>
               </a:ext>
             </a:extLst>
           </p:cNvPr>
@@ -3474,7 +3474,7 @@
           <p:cNvPr id="12" name="">
             <a:extLst xmlns:a="http://schemas.openxmlformats.org/drawingml/2006/main">
               <a:ext uri="{FF2B5EF4-FFF2-40B4-BE49-F238E27FC236}">
-                <a16:creationId xmlns:a16="http://schemas.microsoft.com/office/drawing/2014/main" id="{E8763B04-A1F6-4274-B18D-5A821A87B0C0}"/>
+                <a16:creationId xmlns:a16="http://schemas.microsoft.com/office/drawing/2014/main" id="{38AC20E7-E703-4F57-BBD9-2D2517004682}"/>
               </a:ext>
             </a:extLst>
           </p:cNvPr>
@@ -3529,7 +3529,7 @@
     </p:spTree>
     <p:extLst>
       <p:ext uri="{BB962C8B-B14F-4D97-AF65-F5344CB8AC3E}">
-        <p14:creationId xmlns:p14="http://schemas.microsoft.com/office/powerpoint/2010/main" val="1137362515"/>
+        <p14:creationId xmlns:p14="http://schemas.microsoft.com/office/powerpoint/2010/main" val="914763562"/>
       </p:ext>
     </p:extLst>
   </p:cSld>
@@ -3560,7 +3560,7 @@
           <p:cNvPr id="12" name="">
             <a:extLst xmlns:a="http://schemas.openxmlformats.org/drawingml/2006/main">
               <a:ext uri="{FF2B5EF4-FFF2-40B4-BE49-F238E27FC236}">
-                <a16:creationId xmlns:a16="http://schemas.microsoft.com/office/drawing/2014/main" id="{0AF92C2A-9CC2-4599-92CC-D3DC235063F3}"/>
+                <a16:creationId xmlns:a16="http://schemas.microsoft.com/office/drawing/2014/main" id="{3F00C59C-ACEF-48BF-9CDA-6EEA98E818C9}"/>
               </a:ext>
             </a:extLst>
           </p:cNvPr>
@@ -3617,7 +3617,7 @@
           <p:cNvPr id="2" name="">
             <a:extLst xmlns:a="http://schemas.openxmlformats.org/drawingml/2006/main">
               <a:ext uri="{FF2B5EF4-FFF2-40B4-BE49-F238E27FC236}">
-                <a16:creationId xmlns:a16="http://schemas.microsoft.com/office/drawing/2014/main" id="{7E201C30-6E30-4C9F-9D92-476DABF99946}"/>
+                <a16:creationId xmlns:a16="http://schemas.microsoft.com/office/drawing/2014/main" id="{1DFABBF7-BE07-4E59-89E4-9E116EE4EFFD}"/>
               </a:ext>
             </a:extLst>
           </p:cNvPr>
@@ -3674,7 +3674,7 @@
           <p:cNvPr id="3" name="">
             <a:extLst xmlns:a="http://schemas.openxmlformats.org/drawingml/2006/main">
               <a:ext uri="{FF2B5EF4-FFF2-40B4-BE49-F238E27FC236}">
-                <a16:creationId xmlns:a16="http://schemas.microsoft.com/office/drawing/2014/main" id="{E6C7F37A-3F13-441D-BF2C-34062E55A33F}"/>
+                <a16:creationId xmlns:a16="http://schemas.microsoft.com/office/drawing/2014/main" id="{DA3BD7F0-D2A7-4849-81A0-EB20ACBC8C2E}"/>
               </a:ext>
             </a:extLst>
           </p:cNvPr>
@@ -3731,7 +3731,7 @@
           <p:cNvPr id="4" name="">
             <a:extLst xmlns:a="http://schemas.openxmlformats.org/drawingml/2006/main">
               <a:ext uri="{FF2B5EF4-FFF2-40B4-BE49-F238E27FC236}">
-                <a16:creationId xmlns:a16="http://schemas.microsoft.com/office/drawing/2014/main" id="{D63843BE-1558-4D42-8260-F2660BA6C8ED}"/>
+                <a16:creationId xmlns:a16="http://schemas.microsoft.com/office/drawing/2014/main" id="{649258B9-B4E7-436B-AB97-14EB4F0099CE}"/>
               </a:ext>
             </a:extLst>
           </p:cNvPr>
@@ -3788,7 +3788,7 @@
           <p:cNvPr id="5" name="">
             <a:extLst xmlns:a="http://schemas.openxmlformats.org/drawingml/2006/main">
               <a:ext uri="{FF2B5EF4-FFF2-40B4-BE49-F238E27FC236}">
-                <a16:creationId xmlns:a16="http://schemas.microsoft.com/office/drawing/2014/main" id="{0F99A313-97F7-4252-90DF-3B66AC6B1A11}"/>
+                <a16:creationId xmlns:a16="http://schemas.microsoft.com/office/drawing/2014/main" id="{65E7F7E8-1CE7-45AF-BA16-B52D7ACD17A7}"/>
               </a:ext>
             </a:extLst>
           </p:cNvPr>
@@ -3845,7 +3845,7 @@
           <p:cNvPr id="6" name="">
             <a:extLst xmlns:a="http://schemas.openxmlformats.org/drawingml/2006/main">
               <a:ext uri="{FF2B5EF4-FFF2-40B4-BE49-F238E27FC236}">
-                <a16:creationId xmlns:a16="http://schemas.microsoft.com/office/drawing/2014/main" id="{B8CCA43C-999C-4A93-BA47-9FCE8DA77D3B}"/>
+                <a16:creationId xmlns:a16="http://schemas.microsoft.com/office/drawing/2014/main" id="{D7FD0EA8-A69C-4AAE-8081-2A7666A4D77F}"/>
               </a:ext>
             </a:extLst>
           </p:cNvPr>
@@ -3902,7 +3902,7 @@
           <p:cNvPr id="7" name="">
             <a:extLst xmlns:a="http://schemas.openxmlformats.org/drawingml/2006/main">
               <a:ext uri="{FF2B5EF4-FFF2-40B4-BE49-F238E27FC236}">
-                <a16:creationId xmlns:a16="http://schemas.microsoft.com/office/drawing/2014/main" id="{203091A8-4C11-4EC6-AD86-F549923D42D6}"/>
+                <a16:creationId xmlns:a16="http://schemas.microsoft.com/office/drawing/2014/main" id="{B8A5C1F1-EAB5-4113-AC4B-5FF0DA416B87}"/>
               </a:ext>
             </a:extLst>
           </p:cNvPr>
@@ -3959,7 +3959,7 @@
           <p:cNvPr id="8" name="">
             <a:extLst xmlns:a="http://schemas.openxmlformats.org/drawingml/2006/main">
               <a:ext uri="{FF2B5EF4-FFF2-40B4-BE49-F238E27FC236}">
-                <a16:creationId xmlns:a16="http://schemas.microsoft.com/office/drawing/2014/main" id="{5C165262-945B-4ED5-8247-027BA5A8E0E0}"/>
+                <a16:creationId xmlns:a16="http://schemas.microsoft.com/office/drawing/2014/main" id="{FCF83B1B-4896-4964-AB83-533AE4832C79}"/>
               </a:ext>
             </a:extLst>
           </p:cNvPr>
@@ -4016,7 +4016,7 @@
           <p:cNvPr id="9" name="">
             <a:extLst xmlns:a="http://schemas.openxmlformats.org/drawingml/2006/main">
               <a:ext uri="{FF2B5EF4-FFF2-40B4-BE49-F238E27FC236}">
-                <a16:creationId xmlns:a16="http://schemas.microsoft.com/office/drawing/2014/main" id="{456268C8-12C9-4114-AC7F-013DE85768CD}"/>
+                <a16:creationId xmlns:a16="http://schemas.microsoft.com/office/drawing/2014/main" id="{3680AC85-B936-4DC5-B62F-EA83C463E400}"/>
               </a:ext>
             </a:extLst>
           </p:cNvPr>
@@ -4073,7 +4073,7 @@
           <p:cNvPr id="10" name="">
             <a:extLst xmlns:a="http://schemas.openxmlformats.org/drawingml/2006/main">
               <a:ext uri="{FF2B5EF4-FFF2-40B4-BE49-F238E27FC236}">
-                <a16:creationId xmlns:a16="http://schemas.microsoft.com/office/drawing/2014/main" id="{2B1AD70E-CD7E-4D29-B8AB-DCC9B0B98CC4}"/>
+                <a16:creationId xmlns:a16="http://schemas.microsoft.com/office/drawing/2014/main" id="{F8705165-87FE-424C-9DA4-6171DF374F73}"/>
               </a:ext>
             </a:extLst>
           </p:cNvPr>
@@ -4130,7 +4130,7 @@
           <p:cNvPr id="11" name="">
             <a:extLst xmlns:a="http://schemas.openxmlformats.org/drawingml/2006/main">
               <a:ext uri="{FF2B5EF4-FFF2-40B4-BE49-F238E27FC236}">
-                <a16:creationId xmlns:a16="http://schemas.microsoft.com/office/drawing/2014/main" id="{DF8F16AA-4EA7-4FA6-A1EE-811613EB343B}"/>
+                <a16:creationId xmlns:a16="http://schemas.microsoft.com/office/drawing/2014/main" id="{08913C86-21BF-4327-A61B-9C116A545572}"/>
               </a:ext>
             </a:extLst>
           </p:cNvPr>
@@ -4185,7 +4185,7 @@
     </p:spTree>
     <p:extLst>
       <p:ext uri="{BB962C8B-B14F-4D97-AF65-F5344CB8AC3E}">
-        <p14:creationId xmlns:p14="http://schemas.microsoft.com/office/powerpoint/2010/main" val="1263742123"/>
+        <p14:creationId xmlns:p14="http://schemas.microsoft.com/office/powerpoint/2010/main" val="75835576"/>
       </p:ext>
     </p:extLst>
   </p:cSld>
@@ -4216,7 +4216,7 @@
           <p:cNvPr id="18" name="">
             <a:extLst xmlns:a="http://schemas.openxmlformats.org/drawingml/2006/main">
               <a:ext uri="{FF2B5EF4-FFF2-40B4-BE49-F238E27FC236}">
-                <a16:creationId xmlns:a16="http://schemas.microsoft.com/office/drawing/2014/main" id="{4C41D974-5475-464B-8DEA-3CB7715E5010}"/>
+                <a16:creationId xmlns:a16="http://schemas.microsoft.com/office/drawing/2014/main" id="{1569BEA1-3C7A-4BD4-9A85-2AF3FCC32603}"/>
               </a:ext>
             </a:extLst>
           </p:cNvPr>
@@ -4273,7 +4273,7 @@
           <p:cNvPr id="2" name="">
             <a:extLst xmlns:a="http://schemas.openxmlformats.org/drawingml/2006/main">
               <a:ext uri="{FF2B5EF4-FFF2-40B4-BE49-F238E27FC236}">
-                <a16:creationId xmlns:a16="http://schemas.microsoft.com/office/drawing/2014/main" id="{A6E8C915-110B-406A-9B09-BD2462EA933E}"/>
+                <a16:creationId xmlns:a16="http://schemas.microsoft.com/office/drawing/2014/main" id="{7A3BF32A-DB25-4949-8DC4-C396161483A4}"/>
               </a:ext>
             </a:extLst>
           </p:cNvPr>
@@ -4330,7 +4330,7 @@
           <p:cNvPr id="3" name="">
             <a:extLst xmlns:a="http://schemas.openxmlformats.org/drawingml/2006/main">
               <a:ext uri="{FF2B5EF4-FFF2-40B4-BE49-F238E27FC236}">
-                <a16:creationId xmlns:a16="http://schemas.microsoft.com/office/drawing/2014/main" id="{2C4DC4F0-C047-4140-AF1D-5694821CA619}"/>
+                <a16:creationId xmlns:a16="http://schemas.microsoft.com/office/drawing/2014/main" id="{6B752FE0-78C7-4123-B41B-C5EC15853F36}"/>
               </a:ext>
             </a:extLst>
           </p:cNvPr>
@@ -4387,7 +4387,7 @@
           <p:cNvPr id="4" name="">
             <a:extLst xmlns:a="http://schemas.openxmlformats.org/drawingml/2006/main">
               <a:ext uri="{FF2B5EF4-FFF2-40B4-BE49-F238E27FC236}">
-                <a16:creationId xmlns:a16="http://schemas.microsoft.com/office/drawing/2014/main" id="{234F9487-5F97-492B-96C8-A556CB1C6454}"/>
+                <a16:creationId xmlns:a16="http://schemas.microsoft.com/office/drawing/2014/main" id="{1FEBE2B7-50EC-424A-B559-4067E2FAD36D}"/>
               </a:ext>
             </a:extLst>
           </p:cNvPr>
@@ -4444,7 +4444,7 @@
           <p:cNvPr id="5" name="">
             <a:extLst xmlns:a="http://schemas.openxmlformats.org/drawingml/2006/main">
               <a:ext uri="{FF2B5EF4-FFF2-40B4-BE49-F238E27FC236}">
-                <a16:creationId xmlns:a16="http://schemas.microsoft.com/office/drawing/2014/main" id="{967C615A-6906-495C-A34A-6BAA8FFE59FF}"/>
+                <a16:creationId xmlns:a16="http://schemas.microsoft.com/office/drawing/2014/main" id="{0D5233CB-683A-4DE2-9769-BE7855716127}"/>
               </a:ext>
             </a:extLst>
           </p:cNvPr>
@@ -4501,7 +4501,7 @@
           <p:cNvPr id="6" name="">
             <a:extLst xmlns:a="http://schemas.openxmlformats.org/drawingml/2006/main">
               <a:ext uri="{FF2B5EF4-FFF2-40B4-BE49-F238E27FC236}">
-                <a16:creationId xmlns:a16="http://schemas.microsoft.com/office/drawing/2014/main" id="{B8716641-D735-49CF-98DF-12FF74D4DC14}"/>
+                <a16:creationId xmlns:a16="http://schemas.microsoft.com/office/drawing/2014/main" id="{4A608D09-875A-4ABF-A7D9-270E4E8D6C92}"/>
               </a:ext>
             </a:extLst>
           </p:cNvPr>
@@ -4558,7 +4558,7 @@
           <p:cNvPr id="7" name="">
             <a:extLst xmlns:a="http://schemas.openxmlformats.org/drawingml/2006/main">
               <a:ext uri="{FF2B5EF4-FFF2-40B4-BE49-F238E27FC236}">
-                <a16:creationId xmlns:a16="http://schemas.microsoft.com/office/drawing/2014/main" id="{00F5AD61-E25E-436E-9EA6-238E8AE150E0}"/>
+                <a16:creationId xmlns:a16="http://schemas.microsoft.com/office/drawing/2014/main" id="{F7DEED39-DBAB-4592-A9E8-207C8FD691C1}"/>
               </a:ext>
             </a:extLst>
           </p:cNvPr>
@@ -4615,7 +4615,7 @@
           <p:cNvPr id="8" name="">
             <a:extLst xmlns:a="http://schemas.openxmlformats.org/drawingml/2006/main">
               <a:ext uri="{FF2B5EF4-FFF2-40B4-BE49-F238E27FC236}">
-                <a16:creationId xmlns:a16="http://schemas.microsoft.com/office/drawing/2014/main" id="{BE0D0F09-C207-4A3F-875A-39F5380254AB}"/>
+                <a16:creationId xmlns:a16="http://schemas.microsoft.com/office/drawing/2014/main" id="{F9910226-EC8B-46E0-90FE-526D6E17CBF6}"/>
               </a:ext>
             </a:extLst>
           </p:cNvPr>
@@ -4672,7 +4672,7 @@
           <p:cNvPr id="9" name="">
             <a:extLst xmlns:a="http://schemas.openxmlformats.org/drawingml/2006/main">
               <a:ext uri="{FF2B5EF4-FFF2-40B4-BE49-F238E27FC236}">
-                <a16:creationId xmlns:a16="http://schemas.microsoft.com/office/drawing/2014/main" id="{86F0BB48-FDD3-4CEA-994D-E81C6EEC1C23}"/>
+                <a16:creationId xmlns:a16="http://schemas.microsoft.com/office/drawing/2014/main" id="{F1DB6C43-BC93-46B1-8F4A-C3686C95796B}"/>
               </a:ext>
             </a:extLst>
           </p:cNvPr>
@@ -4729,7 +4729,7 @@
           <p:cNvPr id="10" name="">
             <a:extLst xmlns:a="http://schemas.openxmlformats.org/drawingml/2006/main">
               <a:ext uri="{FF2B5EF4-FFF2-40B4-BE49-F238E27FC236}">
-                <a16:creationId xmlns:a16="http://schemas.microsoft.com/office/drawing/2014/main" id="{206E4E86-D123-4573-B4E7-C4A9DDF09FA3}"/>
+                <a16:creationId xmlns:a16="http://schemas.microsoft.com/office/drawing/2014/main" id="{454AB657-57D3-4531-9137-98275C1B9D54}"/>
               </a:ext>
             </a:extLst>
           </p:cNvPr>
@@ -4786,7 +4786,7 @@
           <p:cNvPr id="11" name="">
             <a:extLst xmlns:a="http://schemas.openxmlformats.org/drawingml/2006/main">
               <a:ext uri="{FF2B5EF4-FFF2-40B4-BE49-F238E27FC236}">
-                <a16:creationId xmlns:a16="http://schemas.microsoft.com/office/drawing/2014/main" id="{D40B9B4D-D0EB-47A1-A16E-56832322454B}"/>
+                <a16:creationId xmlns:a16="http://schemas.microsoft.com/office/drawing/2014/main" id="{62FBF4E3-8C7A-46B6-8110-D8BA894E89D6}"/>
               </a:ext>
             </a:extLst>
           </p:cNvPr>
@@ -4843,7 +4843,7 @@
           <p:cNvPr id="12" name="">
             <a:extLst xmlns:a="http://schemas.openxmlformats.org/drawingml/2006/main">
               <a:ext uri="{FF2B5EF4-FFF2-40B4-BE49-F238E27FC236}">
-                <a16:creationId xmlns:a16="http://schemas.microsoft.com/office/drawing/2014/main" id="{4A23A915-8212-466F-BB61-7A506AC2C773}"/>
+                <a16:creationId xmlns:a16="http://schemas.microsoft.com/office/drawing/2014/main" id="{91BFAEBA-8D38-45DE-879E-AD6BFA7E9607}"/>
               </a:ext>
             </a:extLst>
           </p:cNvPr>
@@ -4900,7 +4900,7 @@
           <p:cNvPr id="13" name="">
             <a:extLst xmlns:a="http://schemas.openxmlformats.org/drawingml/2006/main">
               <a:ext uri="{FF2B5EF4-FFF2-40B4-BE49-F238E27FC236}">
-                <a16:creationId xmlns:a16="http://schemas.microsoft.com/office/drawing/2014/main" id="{6CFC1194-9B0D-4635-BD0E-4C2C8B94238A}"/>
+                <a16:creationId xmlns:a16="http://schemas.microsoft.com/office/drawing/2014/main" id="{E27F01B7-B966-4832-A6FE-D0622A483F13}"/>
               </a:ext>
             </a:extLst>
           </p:cNvPr>
@@ -4957,7 +4957,7 @@
           <p:cNvPr id="14" name="">
             <a:extLst xmlns:a="http://schemas.openxmlformats.org/drawingml/2006/main">
               <a:ext uri="{FF2B5EF4-FFF2-40B4-BE49-F238E27FC236}">
-                <a16:creationId xmlns:a16="http://schemas.microsoft.com/office/drawing/2014/main" id="{7B4FC4CD-F62B-4AD3-89D0-B917E5DFF5B9}"/>
+                <a16:creationId xmlns:a16="http://schemas.microsoft.com/office/drawing/2014/main" id="{EFA31854-AACB-4C03-A672-1797C64F25FA}"/>
               </a:ext>
             </a:extLst>
           </p:cNvPr>
@@ -5014,7 +5014,7 @@
           <p:cNvPr id="15" name="">
             <a:extLst xmlns:a="http://schemas.openxmlformats.org/drawingml/2006/main">
               <a:ext uri="{FF2B5EF4-FFF2-40B4-BE49-F238E27FC236}">
-                <a16:creationId xmlns:a16="http://schemas.microsoft.com/office/drawing/2014/main" id="{A208D31F-AF8C-4EBD-8C0E-D7493ED71D73}"/>
+                <a16:creationId xmlns:a16="http://schemas.microsoft.com/office/drawing/2014/main" id="{F5DAF00A-8D97-44B7-994D-A80A6EFA76D6}"/>
               </a:ext>
             </a:extLst>
           </p:cNvPr>
@@ -5071,7 +5071,7 @@
           <p:cNvPr id="16" name="">
             <a:extLst xmlns:a="http://schemas.openxmlformats.org/drawingml/2006/main">
               <a:ext uri="{FF2B5EF4-FFF2-40B4-BE49-F238E27FC236}">
-                <a16:creationId xmlns:a16="http://schemas.microsoft.com/office/drawing/2014/main" id="{EB3F3F35-0A28-46CC-97B0-6A8474FDEDFC}"/>
+                <a16:creationId xmlns:a16="http://schemas.microsoft.com/office/drawing/2014/main" id="{6B9FA72E-757A-4FAD-8E30-7C99D15185DE}"/>
               </a:ext>
             </a:extLst>
           </p:cNvPr>
@@ -5128,7 +5128,7 @@
           <p:cNvPr id="17" name="">
             <a:extLst xmlns:a="http://schemas.openxmlformats.org/drawingml/2006/main">
               <a:ext uri="{FF2B5EF4-FFF2-40B4-BE49-F238E27FC236}">
-                <a16:creationId xmlns:a16="http://schemas.microsoft.com/office/drawing/2014/main" id="{A48CF7D8-91AC-450E-801D-5178FC7CD7D8}"/>
+                <a16:creationId xmlns:a16="http://schemas.microsoft.com/office/drawing/2014/main" id="{EA692C9B-7157-44C6-86D4-CFF1EF5EC339}"/>
               </a:ext>
             </a:extLst>
           </p:cNvPr>
@@ -5183,7 +5183,7 @@
     </p:spTree>
     <p:extLst>
       <p:ext uri="{BB962C8B-B14F-4D97-AF65-F5344CB8AC3E}">
-        <p14:creationId xmlns:p14="http://schemas.microsoft.com/office/powerpoint/2010/main" val="274607502"/>
+        <p14:creationId xmlns:p14="http://schemas.microsoft.com/office/powerpoint/2010/main" val="1662336619"/>
       </p:ext>
     </p:extLst>
   </p:cSld>
@@ -5214,7 +5214,7 @@
           <p:cNvPr id="10" name="">
             <a:extLst xmlns:a="http://schemas.openxmlformats.org/drawingml/2006/main">
               <a:ext uri="{FF2B5EF4-FFF2-40B4-BE49-F238E27FC236}">
-                <a16:creationId xmlns:a16="http://schemas.microsoft.com/office/drawing/2014/main" id="{36A61A6A-97AE-4D9A-9811-49250F12EF30}"/>
+                <a16:creationId xmlns:a16="http://schemas.microsoft.com/office/drawing/2014/main" id="{065B5503-DA35-44DE-969B-91925B412372}"/>
               </a:ext>
             </a:extLst>
           </p:cNvPr>
@@ -5271,7 +5271,7 @@
           <p:cNvPr id="2" name="">
             <a:extLst xmlns:a="http://schemas.openxmlformats.org/drawingml/2006/main">
               <a:ext uri="{FF2B5EF4-FFF2-40B4-BE49-F238E27FC236}">
-                <a16:creationId xmlns:a16="http://schemas.microsoft.com/office/drawing/2014/main" id="{53B1990E-D3E2-452B-B2EF-0B61CE7562A5}"/>
+                <a16:creationId xmlns:a16="http://schemas.microsoft.com/office/drawing/2014/main" id="{0F462DE7-4289-496B-A749-1FB621945F23}"/>
               </a:ext>
             </a:extLst>
           </p:cNvPr>
@@ -5328,7 +5328,7 @@
           <p:cNvPr id="3" name="">
             <a:extLst xmlns:a="http://schemas.openxmlformats.org/drawingml/2006/main">
               <a:ext uri="{FF2B5EF4-FFF2-40B4-BE49-F238E27FC236}">
-                <a16:creationId xmlns:a16="http://schemas.microsoft.com/office/drawing/2014/main" id="{463D2F56-82A7-48A3-8E3C-618BF8488E69}"/>
+                <a16:creationId xmlns:a16="http://schemas.microsoft.com/office/drawing/2014/main" id="{4FCAEDDC-6EF0-482B-B2E9-6CD593C541D7}"/>
               </a:ext>
             </a:extLst>
           </p:cNvPr>
@@ -5385,7 +5385,7 @@
           <p:cNvPr id="4" name="">
             <a:extLst xmlns:a="http://schemas.openxmlformats.org/drawingml/2006/main">
               <a:ext uri="{FF2B5EF4-FFF2-40B4-BE49-F238E27FC236}">
-                <a16:creationId xmlns:a16="http://schemas.microsoft.com/office/drawing/2014/main" id="{3E6C21ED-6B10-4D6C-86FA-627E72BAF111}"/>
+                <a16:creationId xmlns:a16="http://schemas.microsoft.com/office/drawing/2014/main" id="{164DCE9F-EE69-43EA-A564-6A67F3EF5771}"/>
               </a:ext>
             </a:extLst>
           </p:cNvPr>
@@ -5442,7 +5442,7 @@
           <p:cNvPr id="5" name="">
             <a:extLst xmlns:a="http://schemas.openxmlformats.org/drawingml/2006/main">
               <a:ext uri="{FF2B5EF4-FFF2-40B4-BE49-F238E27FC236}">
-                <a16:creationId xmlns:a16="http://schemas.microsoft.com/office/drawing/2014/main" id="{F7554489-251B-4458-8679-175613DE7476}"/>
+                <a16:creationId xmlns:a16="http://schemas.microsoft.com/office/drawing/2014/main" id="{E41CD131-DD8C-44FF-A0A8-0BCB0F3110BB}"/>
               </a:ext>
             </a:extLst>
           </p:cNvPr>
@@ -5499,7 +5499,7 @@
           <p:cNvPr id="6" name="">
             <a:extLst xmlns:a="http://schemas.openxmlformats.org/drawingml/2006/main">
               <a:ext uri="{FF2B5EF4-FFF2-40B4-BE49-F238E27FC236}">
-                <a16:creationId xmlns:a16="http://schemas.microsoft.com/office/drawing/2014/main" id="{479E53ED-5F2D-43FC-A9EC-A10EFDD4F551}"/>
+                <a16:creationId xmlns:a16="http://schemas.microsoft.com/office/drawing/2014/main" id="{BD9FB81B-C27E-4314-9DCE-C146222A6CED}"/>
               </a:ext>
             </a:extLst>
           </p:cNvPr>
@@ -5556,7 +5556,7 @@
           <p:cNvPr id="7" name="">
             <a:extLst xmlns:a="http://schemas.openxmlformats.org/drawingml/2006/main">
               <a:ext uri="{FF2B5EF4-FFF2-40B4-BE49-F238E27FC236}">
-                <a16:creationId xmlns:a16="http://schemas.microsoft.com/office/drawing/2014/main" id="{BCEC9F94-6CD9-4758-9ED9-B5E8D7366150}"/>
+                <a16:creationId xmlns:a16="http://schemas.microsoft.com/office/drawing/2014/main" id="{78C837CA-2F63-4EEE-9532-AD47FA020B6C}"/>
               </a:ext>
             </a:extLst>
           </p:cNvPr>
@@ -5613,7 +5613,7 @@
           <p:cNvPr id="8" name="">
             <a:extLst xmlns:a="http://schemas.openxmlformats.org/drawingml/2006/main">
               <a:ext uri="{FF2B5EF4-FFF2-40B4-BE49-F238E27FC236}">
-                <a16:creationId xmlns:a16="http://schemas.microsoft.com/office/drawing/2014/main" id="{8528ECAC-5BF1-48F6-954B-4F75DC672E9E}"/>
+                <a16:creationId xmlns:a16="http://schemas.microsoft.com/office/drawing/2014/main" id="{DB8DAD2A-AA92-4246-8380-0F3C8ADC7AEA}"/>
               </a:ext>
             </a:extLst>
           </p:cNvPr>
@@ -5670,7 +5670,7 @@
           <p:cNvPr id="9" name="">
             <a:extLst xmlns:a="http://schemas.openxmlformats.org/drawingml/2006/main">
               <a:ext uri="{FF2B5EF4-FFF2-40B4-BE49-F238E27FC236}">
-                <a16:creationId xmlns:a16="http://schemas.microsoft.com/office/drawing/2014/main" id="{2EF63D4D-CD8A-4FBA-98FA-83948FEA4204}"/>
+                <a16:creationId xmlns:a16="http://schemas.microsoft.com/office/drawing/2014/main" id="{14580AF3-F791-4147-8241-CCE41EB41753}"/>
               </a:ext>
             </a:extLst>
           </p:cNvPr>
@@ -5725,7 +5725,7 @@
     </p:spTree>
     <p:extLst>
       <p:ext uri="{BB962C8B-B14F-4D97-AF65-F5344CB8AC3E}">
-        <p14:creationId xmlns:p14="http://schemas.microsoft.com/office/powerpoint/2010/main" val="705527419"/>
+        <p14:creationId xmlns:p14="http://schemas.microsoft.com/office/powerpoint/2010/main" val="128808232"/>
       </p:ext>
     </p:extLst>
   </p:cSld>
@@ -5756,7 +5756,7 @@
           <p:cNvPr id="14" name="">
             <a:extLst xmlns:a="http://schemas.openxmlformats.org/drawingml/2006/main">
               <a:ext uri="{FF2B5EF4-FFF2-40B4-BE49-F238E27FC236}">
-                <a16:creationId xmlns:a16="http://schemas.microsoft.com/office/drawing/2014/main" id="{DE6E7123-58D6-4977-B2E8-763602AA0461}"/>
+                <a16:creationId xmlns:a16="http://schemas.microsoft.com/office/drawing/2014/main" id="{7A811CE3-F803-4BCB-A654-D7507F1E7E99}"/>
               </a:ext>
             </a:extLst>
           </p:cNvPr>
@@ -5813,7 +5813,7 @@
           <p:cNvPr id="2" name="">
             <a:extLst xmlns:a="http://schemas.openxmlformats.org/drawingml/2006/main">
               <a:ext uri="{FF2B5EF4-FFF2-40B4-BE49-F238E27FC236}">
-                <a16:creationId xmlns:a16="http://schemas.microsoft.com/office/drawing/2014/main" id="{7715BB13-C998-4CF8-AF04-5F83B4222986}"/>
+                <a16:creationId xmlns:a16="http://schemas.microsoft.com/office/drawing/2014/main" id="{4CB63751-2EC7-4BF1-A3D5-A71DA63E3417}"/>
               </a:ext>
             </a:extLst>
           </p:cNvPr>
@@ -5870,7 +5870,7 @@
           <p:cNvPr id="3" name="">
             <a:extLst xmlns:a="http://schemas.openxmlformats.org/drawingml/2006/main">
               <a:ext uri="{FF2B5EF4-FFF2-40B4-BE49-F238E27FC236}">
-                <a16:creationId xmlns:a16="http://schemas.microsoft.com/office/drawing/2014/main" id="{0A5FA8FC-5AA1-454A-9FEC-F57D39B722F7}"/>
+                <a16:creationId xmlns:a16="http://schemas.microsoft.com/office/drawing/2014/main" id="{712D5018-B1F0-4F24-A437-552C3A7E0454}"/>
               </a:ext>
             </a:extLst>
           </p:cNvPr>
@@ -5927,7 +5927,7 @@
           <p:cNvPr id="4" name="">
             <a:extLst xmlns:a="http://schemas.openxmlformats.org/drawingml/2006/main">
               <a:ext uri="{FF2B5EF4-FFF2-40B4-BE49-F238E27FC236}">
-                <a16:creationId xmlns:a16="http://schemas.microsoft.com/office/drawing/2014/main" id="{A0F50894-D56A-4629-8944-51E30360B09E}"/>
+                <a16:creationId xmlns:a16="http://schemas.microsoft.com/office/drawing/2014/main" id="{20587D98-2920-43B0-A15F-542E7F408874}"/>
               </a:ext>
             </a:extLst>
           </p:cNvPr>
@@ -5944,6 +5944,7 @@
           <a:prstGeom xmlns:a="http://schemas.openxmlformats.org/drawingml/2006/main" prst="rect">
             <a:avLst/>
           </a:prstGeom>
+          <a:noFill xmlns:a="http://schemas.openxmlformats.org/drawingml/2006/main"/>
           <a:ln xmlns:a="http://schemas.openxmlformats.org/drawingml/2006/main" w="0">
             <a:noFill/>
           </a:ln>
@@ -5957,7 +5958,7 @@
             <a:pPr>
               <a:defRPr sz="2100" b="1">
                 <a:solidFill>
-                  <a:srgbClr val="071411"/>
+                  <a:srgbClr val="5CFF67"/>
                 </a:solidFill>
                 <a:latin typeface="Helvetica Neue"/>
                 <a:ea typeface="Helvetica Neue"/>
@@ -5967,7 +5968,7 @@
             <a:r>
               <a:rPr sz="2100" b="1">
                 <a:solidFill>
-                  <a:srgbClr val="071411"/>
+                  <a:srgbClr val="5CFF67"/>
                 </a:solidFill>
                 <a:latin typeface="Helvetica Neue"/>
                 <a:ea typeface="Helvetica Neue"/>
@@ -5983,7 +5984,7 @@
           <p:cNvPr id="5" name="">
             <a:extLst xmlns:a="http://schemas.openxmlformats.org/drawingml/2006/main">
               <a:ext uri="{FF2B5EF4-FFF2-40B4-BE49-F238E27FC236}">
-                <a16:creationId xmlns:a16="http://schemas.microsoft.com/office/drawing/2014/main" id="{400190DD-BD96-4F6B-B652-11AFE8132A92}"/>
+                <a16:creationId xmlns:a16="http://schemas.microsoft.com/office/drawing/2014/main" id="{C3C8FADE-4A9C-4E35-85D9-59C5A5765F17}"/>
               </a:ext>
             </a:extLst>
           </p:cNvPr>
@@ -6040,7 +6041,7 @@
           <p:cNvPr id="6" name="">
             <a:extLst xmlns:a="http://schemas.openxmlformats.org/drawingml/2006/main">
               <a:ext uri="{FF2B5EF4-FFF2-40B4-BE49-F238E27FC236}">
-                <a16:creationId xmlns:a16="http://schemas.microsoft.com/office/drawing/2014/main" id="{0EC3DB09-D4EB-4CAB-A5A4-A5958543CE88}"/>
+                <a16:creationId xmlns:a16="http://schemas.microsoft.com/office/drawing/2014/main" id="{E73A2D78-1D3B-4915-9111-E294B115C70C}"/>
               </a:ext>
             </a:extLst>
           </p:cNvPr>
@@ -6057,6 +6058,7 @@
           <a:prstGeom xmlns:a="http://schemas.openxmlformats.org/drawingml/2006/main" prst="rect">
             <a:avLst/>
           </a:prstGeom>
+          <a:noFill xmlns:a="http://schemas.openxmlformats.org/drawingml/2006/main"/>
           <a:ln xmlns:a="http://schemas.openxmlformats.org/drawingml/2006/main" w="0">
             <a:noFill/>
           </a:ln>
@@ -6070,7 +6072,7 @@
             <a:pPr>
               <a:defRPr sz="2100" b="1">
                 <a:solidFill>
-                  <a:srgbClr val="071411"/>
+                  <a:srgbClr val="5CFF67"/>
                 </a:solidFill>
                 <a:latin typeface="Helvetica Neue"/>
                 <a:ea typeface="Helvetica Neue"/>
@@ -6080,7 +6082,7 @@
             <a:r>
               <a:rPr sz="2100" b="1">
                 <a:solidFill>
-                  <a:srgbClr val="071411"/>
+                  <a:srgbClr val="5CFF67"/>
                 </a:solidFill>
                 <a:latin typeface="Helvetica Neue"/>
                 <a:ea typeface="Helvetica Neue"/>
@@ -6096,7 +6098,7 @@
           <p:cNvPr id="7" name="">
             <a:extLst xmlns:a="http://schemas.openxmlformats.org/drawingml/2006/main">
               <a:ext uri="{FF2B5EF4-FFF2-40B4-BE49-F238E27FC236}">
-                <a16:creationId xmlns:a16="http://schemas.microsoft.com/office/drawing/2014/main" id="{643B4171-3253-4EC9-B891-D79D55C98715}"/>
+                <a16:creationId xmlns:a16="http://schemas.microsoft.com/office/drawing/2014/main" id="{D6CC2806-8D8A-4D65-9FDC-75BEC024B6B2}"/>
               </a:ext>
             </a:extLst>
           </p:cNvPr>
@@ -6153,7 +6155,7 @@
           <p:cNvPr id="8" name="">
             <a:extLst xmlns:a="http://schemas.openxmlformats.org/drawingml/2006/main">
               <a:ext uri="{FF2B5EF4-FFF2-40B4-BE49-F238E27FC236}">
-                <a16:creationId xmlns:a16="http://schemas.microsoft.com/office/drawing/2014/main" id="{20AC95DF-29CD-4EAC-8275-91AC0717B3E1}"/>
+                <a16:creationId xmlns:a16="http://schemas.microsoft.com/office/drawing/2014/main" id="{4A8DD33D-7431-468F-80A4-5AC81B8E02BE}"/>
               </a:ext>
             </a:extLst>
           </p:cNvPr>
@@ -6170,6 +6172,7 @@
           <a:prstGeom xmlns:a="http://schemas.openxmlformats.org/drawingml/2006/main" prst="rect">
             <a:avLst/>
           </a:prstGeom>
+          <a:noFill xmlns:a="http://schemas.openxmlformats.org/drawingml/2006/main"/>
           <a:ln xmlns:a="http://schemas.openxmlformats.org/drawingml/2006/main" w="0">
             <a:noFill/>
           </a:ln>
@@ -6183,7 +6186,7 @@
             <a:pPr>
               <a:defRPr sz="2100" b="1">
                 <a:solidFill>
-                  <a:srgbClr val="071411"/>
+                  <a:srgbClr val="5CFF67"/>
                 </a:solidFill>
                 <a:latin typeface="Helvetica Neue"/>
                 <a:ea typeface="Helvetica Neue"/>
@@ -6193,7 +6196,7 @@
             <a:r>
               <a:rPr sz="2100" b="1">
                 <a:solidFill>
-                  <a:srgbClr val="071411"/>
+                  <a:srgbClr val="5CFF67"/>
                 </a:solidFill>
                 <a:latin typeface="Helvetica Neue"/>
                 <a:ea typeface="Helvetica Neue"/>
@@ -6209,7 +6212,7 @@
           <p:cNvPr id="9" name="">
             <a:extLst xmlns:a="http://schemas.openxmlformats.org/drawingml/2006/main">
               <a:ext uri="{FF2B5EF4-FFF2-40B4-BE49-F238E27FC236}">
-                <a16:creationId xmlns:a16="http://schemas.microsoft.com/office/drawing/2014/main" id="{BEED9ED2-9004-4F82-86AB-E5AD3E2D1E40}"/>
+                <a16:creationId xmlns:a16="http://schemas.microsoft.com/office/drawing/2014/main" id="{78CE4982-F5B1-4877-BDBC-F2E9F377D3E6}"/>
               </a:ext>
             </a:extLst>
           </p:cNvPr>
@@ -6266,7 +6269,7 @@
           <p:cNvPr id="10" name="">
             <a:extLst xmlns:a="http://schemas.openxmlformats.org/drawingml/2006/main">
               <a:ext uri="{FF2B5EF4-FFF2-40B4-BE49-F238E27FC236}">
-                <a16:creationId xmlns:a16="http://schemas.microsoft.com/office/drawing/2014/main" id="{171E3F9F-7E22-45EA-84BB-F93401FFEE8B}"/>
+                <a16:creationId xmlns:a16="http://schemas.microsoft.com/office/drawing/2014/main" id="{5F1D0286-F4BF-4256-B767-9E8B7A3DAF60}"/>
               </a:ext>
             </a:extLst>
           </p:cNvPr>
@@ -6283,6 +6286,7 @@
           <a:prstGeom xmlns:a="http://schemas.openxmlformats.org/drawingml/2006/main" prst="rect">
             <a:avLst/>
           </a:prstGeom>
+          <a:noFill xmlns:a="http://schemas.openxmlformats.org/drawingml/2006/main"/>
           <a:ln xmlns:a="http://schemas.openxmlformats.org/drawingml/2006/main" w="0">
             <a:noFill/>
           </a:ln>
@@ -6296,7 +6300,7 @@
             <a:pPr>
               <a:defRPr sz="2100" b="1">
                 <a:solidFill>
-                  <a:srgbClr val="071411"/>
+                  <a:srgbClr val="5CFF67"/>
                 </a:solidFill>
                 <a:latin typeface="Helvetica Neue"/>
                 <a:ea typeface="Helvetica Neue"/>
@@ -6306,7 +6310,7 @@
             <a:r>
               <a:rPr sz="2100" b="1">
                 <a:solidFill>
-                  <a:srgbClr val="071411"/>
+                  <a:srgbClr val="5CFF67"/>
                 </a:solidFill>
                 <a:latin typeface="Helvetica Neue"/>
                 <a:ea typeface="Helvetica Neue"/>
@@ -6322,7 +6326,7 @@
           <p:cNvPr id="11" name="">
             <a:extLst xmlns:a="http://schemas.openxmlformats.org/drawingml/2006/main">
               <a:ext uri="{FF2B5EF4-FFF2-40B4-BE49-F238E27FC236}">
-                <a16:creationId xmlns:a16="http://schemas.microsoft.com/office/drawing/2014/main" id="{3BC1EE3D-CE84-4952-8CC5-D5B486EF4439}"/>
+                <a16:creationId xmlns:a16="http://schemas.microsoft.com/office/drawing/2014/main" id="{4A03241C-5FC2-4C75-A3EF-80D8358EF725}"/>
               </a:ext>
             </a:extLst>
           </p:cNvPr>
@@ -6379,7 +6383,7 @@
           <p:cNvPr id="12" name="">
             <a:extLst xmlns:a="http://schemas.openxmlformats.org/drawingml/2006/main">
               <a:ext uri="{FF2B5EF4-FFF2-40B4-BE49-F238E27FC236}">
-                <a16:creationId xmlns:a16="http://schemas.microsoft.com/office/drawing/2014/main" id="{1AC144A9-C57F-4A9D-AC52-32F88427CD78}"/>
+                <a16:creationId xmlns:a16="http://schemas.microsoft.com/office/drawing/2014/main" id="{7DDCBEF8-458C-43F3-86CA-933DF8E58CDF}"/>
               </a:ext>
             </a:extLst>
           </p:cNvPr>
@@ -6436,7 +6440,7 @@
           <p:cNvPr id="13" name="">
             <a:extLst xmlns:a="http://schemas.openxmlformats.org/drawingml/2006/main">
               <a:ext uri="{FF2B5EF4-FFF2-40B4-BE49-F238E27FC236}">
-                <a16:creationId xmlns:a16="http://schemas.microsoft.com/office/drawing/2014/main" id="{5681BA07-9D5B-481C-9EEA-E891794584E4}"/>
+                <a16:creationId xmlns:a16="http://schemas.microsoft.com/office/drawing/2014/main" id="{E8E6CF09-BFA9-4DAF-8E8D-1803DF8F2B0A}"/>
               </a:ext>
             </a:extLst>
           </p:cNvPr>
@@ -6491,7 +6495,7 @@
     </p:spTree>
     <p:extLst>
       <p:ext uri="{BB962C8B-B14F-4D97-AF65-F5344CB8AC3E}">
-        <p14:creationId xmlns:p14="http://schemas.microsoft.com/office/powerpoint/2010/main" val="1610185162"/>
+        <p14:creationId xmlns:p14="http://schemas.microsoft.com/office/powerpoint/2010/main" val="2078667581"/>
       </p:ext>
     </p:extLst>
   </p:cSld>
@@ -6522,7 +6526,7 @@
           <p:cNvPr id="15" name="">
             <a:extLst xmlns:a="http://schemas.openxmlformats.org/drawingml/2006/main">
               <a:ext uri="{FF2B5EF4-FFF2-40B4-BE49-F238E27FC236}">
-                <a16:creationId xmlns:a16="http://schemas.microsoft.com/office/drawing/2014/main" id="{D1EB173A-615F-4640-A6BD-830149790BAC}"/>
+                <a16:creationId xmlns:a16="http://schemas.microsoft.com/office/drawing/2014/main" id="{699E28E2-4FE7-4D82-85B5-A20DF777FE5D}"/>
               </a:ext>
             </a:extLst>
           </p:cNvPr>
@@ -6579,7 +6583,7 @@
           <p:cNvPr id="2" name="">
             <a:extLst xmlns:a="http://schemas.openxmlformats.org/drawingml/2006/main">
               <a:ext uri="{FF2B5EF4-FFF2-40B4-BE49-F238E27FC236}">
-                <a16:creationId xmlns:a16="http://schemas.microsoft.com/office/drawing/2014/main" id="{DEA8BB91-8000-4AE2-95D8-071D64BB0E5D}"/>
+                <a16:creationId xmlns:a16="http://schemas.microsoft.com/office/drawing/2014/main" id="{7EA387F0-70D2-436A-B669-FD7277A15BD8}"/>
               </a:ext>
             </a:extLst>
           </p:cNvPr>
@@ -6636,7 +6640,7 @@
           <p:cNvPr id="3" name="">
             <a:extLst xmlns:a="http://schemas.openxmlformats.org/drawingml/2006/main">
               <a:ext uri="{FF2B5EF4-FFF2-40B4-BE49-F238E27FC236}">
-                <a16:creationId xmlns:a16="http://schemas.microsoft.com/office/drawing/2014/main" id="{CAAC6AA6-DEB1-4299-8221-DA6A5312A842}"/>
+                <a16:creationId xmlns:a16="http://schemas.microsoft.com/office/drawing/2014/main" id="{15EE3008-4F83-43B9-B37C-7E96F9D81E77}"/>
               </a:ext>
             </a:extLst>
           </p:cNvPr>
@@ -6693,7 +6697,7 @@
           <p:cNvPr id="4" name="">
             <a:extLst xmlns:a="http://schemas.openxmlformats.org/drawingml/2006/main">
               <a:ext uri="{FF2B5EF4-FFF2-40B4-BE49-F238E27FC236}">
-                <a16:creationId xmlns:a16="http://schemas.microsoft.com/office/drawing/2014/main" id="{44AED834-6AEC-483E-A72F-287361D5B92E}"/>
+                <a16:creationId xmlns:a16="http://schemas.microsoft.com/office/drawing/2014/main" id="{C3FF085C-5F08-4553-B80B-588619C7C0AD}"/>
               </a:ext>
             </a:extLst>
           </p:cNvPr>
@@ -6750,7 +6754,7 @@
           <p:cNvPr id="5" name="">
             <a:extLst xmlns:a="http://schemas.openxmlformats.org/drawingml/2006/main">
               <a:ext uri="{FF2B5EF4-FFF2-40B4-BE49-F238E27FC236}">
-                <a16:creationId xmlns:a16="http://schemas.microsoft.com/office/drawing/2014/main" id="{39B3F580-8DC8-4BE6-9E06-A93CED2847E2}"/>
+                <a16:creationId xmlns:a16="http://schemas.microsoft.com/office/drawing/2014/main" id="{4654B4CF-B21D-4F98-B3BC-E9AA287AA523}"/>
               </a:ext>
             </a:extLst>
           </p:cNvPr>
@@ -6807,7 +6811,7 @@
           <p:cNvPr id="6" name="">
             <a:extLst xmlns:a="http://schemas.openxmlformats.org/drawingml/2006/main">
               <a:ext uri="{FF2B5EF4-FFF2-40B4-BE49-F238E27FC236}">
-                <a16:creationId xmlns:a16="http://schemas.microsoft.com/office/drawing/2014/main" id="{7F5503FF-23D7-4D69-AC19-EB5EF494B90A}"/>
+                <a16:creationId xmlns:a16="http://schemas.microsoft.com/office/drawing/2014/main" id="{6D9E7836-36CD-48AA-BB4B-785AFD6E3737}"/>
               </a:ext>
             </a:extLst>
           </p:cNvPr>
@@ -6864,7 +6868,7 @@
           <p:cNvPr id="7" name="">
             <a:extLst xmlns:a="http://schemas.openxmlformats.org/drawingml/2006/main">
               <a:ext uri="{FF2B5EF4-FFF2-40B4-BE49-F238E27FC236}">
-                <a16:creationId xmlns:a16="http://schemas.microsoft.com/office/drawing/2014/main" id="{D0864E5D-CD12-41FB-91BE-8ED770B2782C}"/>
+                <a16:creationId xmlns:a16="http://schemas.microsoft.com/office/drawing/2014/main" id="{33E23E5A-D85C-404E-91BB-14F6AE04807A}"/>
               </a:ext>
             </a:extLst>
           </p:cNvPr>
@@ -6921,7 +6925,7 @@
           <p:cNvPr id="8" name="">
             <a:extLst xmlns:a="http://schemas.openxmlformats.org/drawingml/2006/main">
               <a:ext uri="{FF2B5EF4-FFF2-40B4-BE49-F238E27FC236}">
-                <a16:creationId xmlns:a16="http://schemas.microsoft.com/office/drawing/2014/main" id="{1BE28749-A046-4057-866D-65A1CCBBB2B9}"/>
+                <a16:creationId xmlns:a16="http://schemas.microsoft.com/office/drawing/2014/main" id="{41AA7EE1-C8A4-4AE4-B41C-522EBDDFF55A}"/>
               </a:ext>
             </a:extLst>
           </p:cNvPr>
@@ -6978,7 +6982,7 @@
           <p:cNvPr id="9" name="">
             <a:extLst xmlns:a="http://schemas.openxmlformats.org/drawingml/2006/main">
               <a:ext uri="{FF2B5EF4-FFF2-40B4-BE49-F238E27FC236}">
-                <a16:creationId xmlns:a16="http://schemas.microsoft.com/office/drawing/2014/main" id="{177337FE-DFE2-4120-9915-4D7D2368172D}"/>
+                <a16:creationId xmlns:a16="http://schemas.microsoft.com/office/drawing/2014/main" id="{7F38B3B1-56EE-4863-9CA7-8819170360D9}"/>
               </a:ext>
             </a:extLst>
           </p:cNvPr>
@@ -7035,7 +7039,7 @@
           <p:cNvPr id="10" name="">
             <a:extLst xmlns:a="http://schemas.openxmlformats.org/drawingml/2006/main">
               <a:ext uri="{FF2B5EF4-FFF2-40B4-BE49-F238E27FC236}">
-                <a16:creationId xmlns:a16="http://schemas.microsoft.com/office/drawing/2014/main" id="{9B9FD57C-5A40-4BA4-9386-9EE1B2C6DFE1}"/>
+                <a16:creationId xmlns:a16="http://schemas.microsoft.com/office/drawing/2014/main" id="{5D11B577-87A9-4935-9ECB-F73FD319A5E5}"/>
               </a:ext>
             </a:extLst>
           </p:cNvPr>
@@ -7092,7 +7096,7 @@
           <p:cNvPr id="11" name="">
             <a:extLst xmlns:a="http://schemas.openxmlformats.org/drawingml/2006/main">
               <a:ext uri="{FF2B5EF4-FFF2-40B4-BE49-F238E27FC236}">
-                <a16:creationId xmlns:a16="http://schemas.microsoft.com/office/drawing/2014/main" id="{DF173799-30D1-40C3-B9D8-1EB541FC0218}"/>
+                <a16:creationId xmlns:a16="http://schemas.microsoft.com/office/drawing/2014/main" id="{A2987ED5-0E83-45F3-A424-EE20D980A2D8}"/>
               </a:ext>
             </a:extLst>
           </p:cNvPr>
@@ -7149,7 +7153,7 @@
           <p:cNvPr id="12" name="">
             <a:extLst xmlns:a="http://schemas.openxmlformats.org/drawingml/2006/main">
               <a:ext uri="{FF2B5EF4-FFF2-40B4-BE49-F238E27FC236}">
-                <a16:creationId xmlns:a16="http://schemas.microsoft.com/office/drawing/2014/main" id="{29FB64C2-D8CF-40C7-BA42-4F70D25C72CA}"/>
+                <a16:creationId xmlns:a16="http://schemas.microsoft.com/office/drawing/2014/main" id="{15EF59C7-AC71-43AF-8356-0ECC5D013898}"/>
               </a:ext>
             </a:extLst>
           </p:cNvPr>
@@ -7206,7 +7210,7 @@
           <p:cNvPr id="13" name="">
             <a:extLst xmlns:a="http://schemas.openxmlformats.org/drawingml/2006/main">
               <a:ext uri="{FF2B5EF4-FFF2-40B4-BE49-F238E27FC236}">
-                <a16:creationId xmlns:a16="http://schemas.microsoft.com/office/drawing/2014/main" id="{7635F111-89D3-41B8-B757-0523AB9701C8}"/>
+                <a16:creationId xmlns:a16="http://schemas.microsoft.com/office/drawing/2014/main" id="{63BADE5A-6E8A-485D-99B4-9FA77F3669B8}"/>
               </a:ext>
             </a:extLst>
           </p:cNvPr>
@@ -7263,7 +7267,7 @@
           <p:cNvPr id="14" name="">
             <a:extLst xmlns:a="http://schemas.openxmlformats.org/drawingml/2006/main">
               <a:ext uri="{FF2B5EF4-FFF2-40B4-BE49-F238E27FC236}">
-                <a16:creationId xmlns:a16="http://schemas.microsoft.com/office/drawing/2014/main" id="{D3C10CA0-DE19-4DF2-AEF2-2472BCDFF957}"/>
+                <a16:creationId xmlns:a16="http://schemas.microsoft.com/office/drawing/2014/main" id="{14A8CAF1-CD51-450C-9C27-9CB77EFB624E}"/>
               </a:ext>
             </a:extLst>
           </p:cNvPr>
@@ -7318,7 +7322,7 @@
     </p:spTree>
     <p:extLst>
       <p:ext uri="{BB962C8B-B14F-4D97-AF65-F5344CB8AC3E}">
-        <p14:creationId xmlns:p14="http://schemas.microsoft.com/office/powerpoint/2010/main" val="1301343344"/>
+        <p14:creationId xmlns:p14="http://schemas.microsoft.com/office/powerpoint/2010/main" val="1050891653"/>
       </p:ext>
     </p:extLst>
   </p:cSld>
@@ -7349,7 +7353,7 @@
           <p:cNvPr id="16" name="">
             <a:extLst xmlns:a="http://schemas.openxmlformats.org/drawingml/2006/main">
               <a:ext uri="{FF2B5EF4-FFF2-40B4-BE49-F238E27FC236}">
-                <a16:creationId xmlns:a16="http://schemas.microsoft.com/office/drawing/2014/main" id="{24CAC96F-A359-479D-985C-85AA6EEA90D5}"/>
+                <a16:creationId xmlns:a16="http://schemas.microsoft.com/office/drawing/2014/main" id="{0431D352-ACEF-45B3-ABF8-1AB08AC62031}"/>
               </a:ext>
             </a:extLst>
           </p:cNvPr>
@@ -7406,7 +7410,7 @@
           <p:cNvPr id="2" name="">
             <a:extLst xmlns:a="http://schemas.openxmlformats.org/drawingml/2006/main">
               <a:ext uri="{FF2B5EF4-FFF2-40B4-BE49-F238E27FC236}">
-                <a16:creationId xmlns:a16="http://schemas.microsoft.com/office/drawing/2014/main" id="{C014DF2B-4103-4F70-A7F0-5063FA33CF4D}"/>
+                <a16:creationId xmlns:a16="http://schemas.microsoft.com/office/drawing/2014/main" id="{039C34A1-6A95-4AF1-95A1-64DE32F91FC6}"/>
               </a:ext>
             </a:extLst>
           </p:cNvPr>
@@ -7463,7 +7467,7 @@
           <p:cNvPr id="3" name="">
             <a:extLst xmlns:a="http://schemas.openxmlformats.org/drawingml/2006/main">
               <a:ext uri="{FF2B5EF4-FFF2-40B4-BE49-F238E27FC236}">
-                <a16:creationId xmlns:a16="http://schemas.microsoft.com/office/drawing/2014/main" id="{13CCA9A2-8432-40CF-BE1E-11CCA8C158C6}"/>
+                <a16:creationId xmlns:a16="http://schemas.microsoft.com/office/drawing/2014/main" id="{508682C3-1CD9-42AC-AF1C-DF96A9FD2341}"/>
               </a:ext>
             </a:extLst>
           </p:cNvPr>
@@ -7520,7 +7524,7 @@
           <p:cNvPr id="4" name="">
             <a:extLst xmlns:a="http://schemas.openxmlformats.org/drawingml/2006/main">
               <a:ext uri="{FF2B5EF4-FFF2-40B4-BE49-F238E27FC236}">
-                <a16:creationId xmlns:a16="http://schemas.microsoft.com/office/drawing/2014/main" id="{6DBB2172-AB86-45FB-B051-6B469A0117FC}"/>
+                <a16:creationId xmlns:a16="http://schemas.microsoft.com/office/drawing/2014/main" id="{5A6635FE-6679-4F1E-9E47-93498AAD4C5B}"/>
               </a:ext>
             </a:extLst>
           </p:cNvPr>
@@ -7537,6 +7541,7 @@
           <a:prstGeom xmlns:a="http://schemas.openxmlformats.org/drawingml/2006/main" prst="rect">
             <a:avLst/>
           </a:prstGeom>
+          <a:noFill xmlns:a="http://schemas.openxmlformats.org/drawingml/2006/main"/>
           <a:ln xmlns:a="http://schemas.openxmlformats.org/drawingml/2006/main" w="0">
             <a:noFill/>
           </a:ln>
@@ -7576,7 +7581,7 @@
           <p:cNvPr id="5" name="">
             <a:extLst xmlns:a="http://schemas.openxmlformats.org/drawingml/2006/main">
               <a:ext uri="{FF2B5EF4-FFF2-40B4-BE49-F238E27FC236}">
-                <a16:creationId xmlns:a16="http://schemas.microsoft.com/office/drawing/2014/main" id="{8DBAC0A3-6272-4ECB-A30F-4B40FB6360E9}"/>
+                <a16:creationId xmlns:a16="http://schemas.microsoft.com/office/drawing/2014/main" id="{A0587FC3-767F-43AA-A014-94EA9FA16020}"/>
               </a:ext>
             </a:extLst>
           </p:cNvPr>
@@ -7633,7 +7638,7 @@
           <p:cNvPr id="6" name="">
             <a:extLst xmlns:a="http://schemas.openxmlformats.org/drawingml/2006/main">
               <a:ext uri="{FF2B5EF4-FFF2-40B4-BE49-F238E27FC236}">
-                <a16:creationId xmlns:a16="http://schemas.microsoft.com/office/drawing/2014/main" id="{0A314E4D-54C1-4C14-9749-81BE46C18CEE}"/>
+                <a16:creationId xmlns:a16="http://schemas.microsoft.com/office/drawing/2014/main" id="{DD2B367E-7314-4941-8D4B-75188825BEBA}"/>
               </a:ext>
             </a:extLst>
           </p:cNvPr>
@@ -7690,7 +7695,7 @@
           <p:cNvPr id="7" name="">
             <a:extLst xmlns:a="http://schemas.openxmlformats.org/drawingml/2006/main">
               <a:ext uri="{FF2B5EF4-FFF2-40B4-BE49-F238E27FC236}">
-                <a16:creationId xmlns:a16="http://schemas.microsoft.com/office/drawing/2014/main" id="{6C0BC490-90C1-41C3-935D-1AD74DAFEE89}"/>
+                <a16:creationId xmlns:a16="http://schemas.microsoft.com/office/drawing/2014/main" id="{47C7B62B-51B7-4958-B14D-640825FE57F9}"/>
               </a:ext>
             </a:extLst>
           </p:cNvPr>
@@ -7707,6 +7712,7 @@
           <a:prstGeom xmlns:a="http://schemas.openxmlformats.org/drawingml/2006/main" prst="rect">
             <a:avLst/>
           </a:prstGeom>
+          <a:noFill xmlns:a="http://schemas.openxmlformats.org/drawingml/2006/main"/>
           <a:ln xmlns:a="http://schemas.openxmlformats.org/drawingml/2006/main" w="0">
             <a:noFill/>
           </a:ln>
@@ -7720,7 +7726,7 @@
             <a:pPr>
               <a:defRPr sz="2025" b="1">
                 <a:solidFill>
-                  <a:srgbClr val="071411"/>
+                  <a:srgbClr val="5CFF67"/>
                 </a:solidFill>
                 <a:latin typeface="Helvetica Neue"/>
                 <a:ea typeface="Helvetica Neue"/>
@@ -7730,7 +7736,7 @@
             <a:r>
               <a:rPr sz="2025" b="1">
                 <a:solidFill>
-                  <a:srgbClr val="071411"/>
+                  <a:srgbClr val="5CFF67"/>
                 </a:solidFill>
                 <a:latin typeface="Helvetica Neue"/>
                 <a:ea typeface="Helvetica Neue"/>
@@ -7746,7 +7752,7 @@
           <p:cNvPr id="8" name="">
             <a:extLst xmlns:a="http://schemas.openxmlformats.org/drawingml/2006/main">
               <a:ext uri="{FF2B5EF4-FFF2-40B4-BE49-F238E27FC236}">
-                <a16:creationId xmlns:a16="http://schemas.microsoft.com/office/drawing/2014/main" id="{49B291D1-ADD2-4490-92A9-D37534358126}"/>
+                <a16:creationId xmlns:a16="http://schemas.microsoft.com/office/drawing/2014/main" id="{8F7E7DD5-C890-4340-8CB1-0F332DF2E4AE}"/>
               </a:ext>
             </a:extLst>
           </p:cNvPr>
@@ -7803,7 +7809,7 @@
           <p:cNvPr id="9" name="">
             <a:extLst xmlns:a="http://schemas.openxmlformats.org/drawingml/2006/main">
               <a:ext uri="{FF2B5EF4-FFF2-40B4-BE49-F238E27FC236}">
-                <a16:creationId xmlns:a16="http://schemas.microsoft.com/office/drawing/2014/main" id="{53FF4F14-4A5C-471C-8BC7-64A3D7C2406A}"/>
+                <a16:creationId xmlns:a16="http://schemas.microsoft.com/office/drawing/2014/main" id="{40D9A3EF-1CED-4A60-A8C5-E22F8BD8B631}"/>
               </a:ext>
             </a:extLst>
           </p:cNvPr>
@@ -7860,7 +7866,7 @@
           <p:cNvPr id="10" name="">
             <a:extLst xmlns:a="http://schemas.openxmlformats.org/drawingml/2006/main">
               <a:ext uri="{FF2B5EF4-FFF2-40B4-BE49-F238E27FC236}">
-                <a16:creationId xmlns:a16="http://schemas.microsoft.com/office/drawing/2014/main" id="{BE194582-61DB-437D-88A8-9E1EA2CE124F}"/>
+                <a16:creationId xmlns:a16="http://schemas.microsoft.com/office/drawing/2014/main" id="{B3976223-818A-449F-AF79-C8CAE0CCF17B}"/>
               </a:ext>
             </a:extLst>
           </p:cNvPr>
@@ -7877,6 +7883,7 @@
           <a:prstGeom xmlns:a="http://schemas.openxmlformats.org/drawingml/2006/main" prst="rect">
             <a:avLst/>
           </a:prstGeom>
+          <a:noFill xmlns:a="http://schemas.openxmlformats.org/drawingml/2006/main"/>
           <a:ln xmlns:a="http://schemas.openxmlformats.org/drawingml/2006/main" w="0">
             <a:noFill/>
           </a:ln>
@@ -7916,7 +7923,7 @@
           <p:cNvPr id="11" name="">
             <a:extLst xmlns:a="http://schemas.openxmlformats.org/drawingml/2006/main">
               <a:ext uri="{FF2B5EF4-FFF2-40B4-BE49-F238E27FC236}">
-                <a16:creationId xmlns:a16="http://schemas.microsoft.com/office/drawing/2014/main" id="{60FD7080-7C93-44C1-ACE7-7E79BF8AB084}"/>
+                <a16:creationId xmlns:a16="http://schemas.microsoft.com/office/drawing/2014/main" id="{8F52219E-1B1E-4082-ABC0-070DD3B9895F}"/>
               </a:ext>
             </a:extLst>
           </p:cNvPr>
@@ -7973,7 +7980,7 @@
           <p:cNvPr id="12" name="">
             <a:extLst xmlns:a="http://schemas.openxmlformats.org/drawingml/2006/main">
               <a:ext uri="{FF2B5EF4-FFF2-40B4-BE49-F238E27FC236}">
-                <a16:creationId xmlns:a16="http://schemas.microsoft.com/office/drawing/2014/main" id="{D95BB35A-A169-4C2D-8310-EDFF72E2A1B0}"/>
+                <a16:creationId xmlns:a16="http://schemas.microsoft.com/office/drawing/2014/main" id="{7AE9CC1F-5425-4DD8-A194-4D352AA17F5D}"/>
               </a:ext>
             </a:extLst>
           </p:cNvPr>
@@ -8030,7 +8037,7 @@
           <p:cNvPr id="13" name="">
             <a:extLst xmlns:a="http://schemas.openxmlformats.org/drawingml/2006/main">
               <a:ext uri="{FF2B5EF4-FFF2-40B4-BE49-F238E27FC236}">
-                <a16:creationId xmlns:a16="http://schemas.microsoft.com/office/drawing/2014/main" id="{D795B94C-B7A4-4068-9E33-9FC71C945FAB}"/>
+                <a16:creationId xmlns:a16="http://schemas.microsoft.com/office/drawing/2014/main" id="{7CAA3D21-625B-46A8-8A20-423BC42CD71A}"/>
               </a:ext>
             </a:extLst>
           </p:cNvPr>
@@ -8047,6 +8054,7 @@
           <a:prstGeom xmlns:a="http://schemas.openxmlformats.org/drawingml/2006/main" prst="rect">
             <a:avLst/>
           </a:prstGeom>
+          <a:noFill xmlns:a="http://schemas.openxmlformats.org/drawingml/2006/main"/>
           <a:ln xmlns:a="http://schemas.openxmlformats.org/drawingml/2006/main" w="0">
             <a:noFill/>
           </a:ln>
@@ -8086,7 +8094,7 @@
           <p:cNvPr id="14" name="">
             <a:extLst xmlns:a="http://schemas.openxmlformats.org/drawingml/2006/main">
               <a:ext uri="{FF2B5EF4-FFF2-40B4-BE49-F238E27FC236}">
-                <a16:creationId xmlns:a16="http://schemas.microsoft.com/office/drawing/2014/main" id="{D338650C-DADE-4F3F-8702-8757873E631D}"/>
+                <a16:creationId xmlns:a16="http://schemas.microsoft.com/office/drawing/2014/main" id="{984710D4-CE7B-4B6B-93B5-648CAC54635C}"/>
               </a:ext>
             </a:extLst>
           </p:cNvPr>
@@ -8143,7 +8151,7 @@
           <p:cNvPr id="15" name="">
             <a:extLst xmlns:a="http://schemas.openxmlformats.org/drawingml/2006/main">
               <a:ext uri="{FF2B5EF4-FFF2-40B4-BE49-F238E27FC236}">
-                <a16:creationId xmlns:a16="http://schemas.microsoft.com/office/drawing/2014/main" id="{337DF292-1046-4819-874A-ABC0BBB932EA}"/>
+                <a16:creationId xmlns:a16="http://schemas.microsoft.com/office/drawing/2014/main" id="{54470592-AEEB-45C0-A0B9-47D71E0169CA}"/>
               </a:ext>
             </a:extLst>
           </p:cNvPr>
@@ -8198,7 +8206,7 @@
     </p:spTree>
     <p:extLst>
       <p:ext uri="{BB962C8B-B14F-4D97-AF65-F5344CB8AC3E}">
-        <p14:creationId xmlns:p14="http://schemas.microsoft.com/office/powerpoint/2010/main" val="96731183"/>
+        <p14:creationId xmlns:p14="http://schemas.microsoft.com/office/powerpoint/2010/main" val="582102223"/>
       </p:ext>
     </p:extLst>
   </p:cSld>
@@ -8229,7 +8237,7 @@
           <p:cNvPr id="14" name="">
             <a:extLst xmlns:a="http://schemas.openxmlformats.org/drawingml/2006/main">
               <a:ext uri="{FF2B5EF4-FFF2-40B4-BE49-F238E27FC236}">
-                <a16:creationId xmlns:a16="http://schemas.microsoft.com/office/drawing/2014/main" id="{16587E04-1B08-4643-8533-DD56527ACAC3}"/>
+                <a16:creationId xmlns:a16="http://schemas.microsoft.com/office/drawing/2014/main" id="{8E2240BA-84BB-4016-BC4E-BAC79B21004F}"/>
               </a:ext>
             </a:extLst>
           </p:cNvPr>
@@ -8286,7 +8294,7 @@
           <p:cNvPr id="2" name="">
             <a:extLst xmlns:a="http://schemas.openxmlformats.org/drawingml/2006/main">
               <a:ext uri="{FF2B5EF4-FFF2-40B4-BE49-F238E27FC236}">
-                <a16:creationId xmlns:a16="http://schemas.microsoft.com/office/drawing/2014/main" id="{072B5BE3-310E-4498-BDA4-21AF39581DF2}"/>
+                <a16:creationId xmlns:a16="http://schemas.microsoft.com/office/drawing/2014/main" id="{17D5A2F9-D12B-47D4-B77A-DEA03FBD3C7B}"/>
               </a:ext>
             </a:extLst>
           </p:cNvPr>
@@ -8343,7 +8351,7 @@
           <p:cNvPr id="3" name="">
             <a:extLst xmlns:a="http://schemas.openxmlformats.org/drawingml/2006/main">
               <a:ext uri="{FF2B5EF4-FFF2-40B4-BE49-F238E27FC236}">
-                <a16:creationId xmlns:a16="http://schemas.microsoft.com/office/drawing/2014/main" id="{5E199EAF-5403-476E-A2F5-28A528AF2817}"/>
+                <a16:creationId xmlns:a16="http://schemas.microsoft.com/office/drawing/2014/main" id="{3584B082-1AEC-4F4E-BBBE-56A797E4B28A}"/>
               </a:ext>
             </a:extLst>
           </p:cNvPr>
@@ -8400,7 +8408,7 @@
           <p:cNvPr id="4" name="">
             <a:extLst xmlns:a="http://schemas.openxmlformats.org/drawingml/2006/main">
               <a:ext uri="{FF2B5EF4-FFF2-40B4-BE49-F238E27FC236}">
-                <a16:creationId xmlns:a16="http://schemas.microsoft.com/office/drawing/2014/main" id="{CD7C3B36-0DB5-420A-BD96-DFE275401DC4}"/>
+                <a16:creationId xmlns:a16="http://schemas.microsoft.com/office/drawing/2014/main" id="{FF73E1CC-7E0C-4539-AC04-0CF2BB4DD9AD}"/>
               </a:ext>
             </a:extLst>
           </p:cNvPr>
@@ -8457,7 +8465,7 @@
           <p:cNvPr id="5" name="">
             <a:extLst xmlns:a="http://schemas.openxmlformats.org/drawingml/2006/main">
               <a:ext uri="{FF2B5EF4-FFF2-40B4-BE49-F238E27FC236}">
-                <a16:creationId xmlns:a16="http://schemas.microsoft.com/office/drawing/2014/main" id="{D8BD56EA-D69F-43D7-84C8-9A19701CC3A8}"/>
+                <a16:creationId xmlns:a16="http://schemas.microsoft.com/office/drawing/2014/main" id="{434431E1-1BB6-411C-92D5-4D9999D00227}"/>
               </a:ext>
             </a:extLst>
           </p:cNvPr>
@@ -8514,7 +8522,7 @@
           <p:cNvPr id="6" name="">
             <a:extLst xmlns:a="http://schemas.openxmlformats.org/drawingml/2006/main">
               <a:ext uri="{FF2B5EF4-FFF2-40B4-BE49-F238E27FC236}">
-                <a16:creationId xmlns:a16="http://schemas.microsoft.com/office/drawing/2014/main" id="{9F2C4B47-71A1-4C9E-9298-94E7C312948A}"/>
+                <a16:creationId xmlns:a16="http://schemas.microsoft.com/office/drawing/2014/main" id="{A9546B7F-5E37-4249-8670-FD8A72383F00}"/>
               </a:ext>
             </a:extLst>
           </p:cNvPr>
@@ -8571,7 +8579,7 @@
           <p:cNvPr id="7" name="">
             <a:extLst xmlns:a="http://schemas.openxmlformats.org/drawingml/2006/main">
               <a:ext uri="{FF2B5EF4-FFF2-40B4-BE49-F238E27FC236}">
-                <a16:creationId xmlns:a16="http://schemas.microsoft.com/office/drawing/2014/main" id="{C64701FC-14CF-468F-9103-E85ED6F5D2C8}"/>
+                <a16:creationId xmlns:a16="http://schemas.microsoft.com/office/drawing/2014/main" id="{BAA79504-CA57-464E-8404-633CD06080C0}"/>
               </a:ext>
             </a:extLst>
           </p:cNvPr>
@@ -8628,7 +8636,7 @@
           <p:cNvPr id="8" name="">
             <a:extLst xmlns:a="http://schemas.openxmlformats.org/drawingml/2006/main">
               <a:ext uri="{FF2B5EF4-FFF2-40B4-BE49-F238E27FC236}">
-                <a16:creationId xmlns:a16="http://schemas.microsoft.com/office/drawing/2014/main" id="{E0804DC4-3C75-4A79-A8C6-31D49B99D54B}"/>
+                <a16:creationId xmlns:a16="http://schemas.microsoft.com/office/drawing/2014/main" id="{4FACCADB-F3A7-405A-BC70-6AB75375A730}"/>
               </a:ext>
             </a:extLst>
           </p:cNvPr>
@@ -8685,7 +8693,7 @@
           <p:cNvPr id="9" name="">
             <a:extLst xmlns:a="http://schemas.openxmlformats.org/drawingml/2006/main">
               <a:ext uri="{FF2B5EF4-FFF2-40B4-BE49-F238E27FC236}">
-                <a16:creationId xmlns:a16="http://schemas.microsoft.com/office/drawing/2014/main" id="{A6B4E259-F073-49A0-B061-EC8A78B22FD8}"/>
+                <a16:creationId xmlns:a16="http://schemas.microsoft.com/office/drawing/2014/main" id="{9DE9489A-61E2-4F72-9FD1-4483CA70B28C}"/>
               </a:ext>
             </a:extLst>
           </p:cNvPr>
@@ -8742,7 +8750,7 @@
           <p:cNvPr id="10" name="">
             <a:extLst xmlns:a="http://schemas.openxmlformats.org/drawingml/2006/main">
               <a:ext uri="{FF2B5EF4-FFF2-40B4-BE49-F238E27FC236}">
-                <a16:creationId xmlns:a16="http://schemas.microsoft.com/office/drawing/2014/main" id="{E9EE1678-A518-49F6-AFD9-E4D37E187B1D}"/>
+                <a16:creationId xmlns:a16="http://schemas.microsoft.com/office/drawing/2014/main" id="{CE0B7799-C43A-475F-813C-BC163F5ED3F3}"/>
               </a:ext>
             </a:extLst>
           </p:cNvPr>
@@ -8799,7 +8807,7 @@
           <p:cNvPr id="11" name="">
             <a:extLst xmlns:a="http://schemas.openxmlformats.org/drawingml/2006/main">
               <a:ext uri="{FF2B5EF4-FFF2-40B4-BE49-F238E27FC236}">
-                <a16:creationId xmlns:a16="http://schemas.microsoft.com/office/drawing/2014/main" id="{909F0FB6-FA71-4EE4-9EE0-43E46360E907}"/>
+                <a16:creationId xmlns:a16="http://schemas.microsoft.com/office/drawing/2014/main" id="{9135C6CF-F10B-403B-85AB-08297276F037}"/>
               </a:ext>
             </a:extLst>
           </p:cNvPr>
@@ -8856,7 +8864,7 @@
           <p:cNvPr id="12" name="">
             <a:extLst xmlns:a="http://schemas.openxmlformats.org/drawingml/2006/main">
               <a:ext uri="{FF2B5EF4-FFF2-40B4-BE49-F238E27FC236}">
-                <a16:creationId xmlns:a16="http://schemas.microsoft.com/office/drawing/2014/main" id="{9972A1E4-E306-47EA-9329-DBE3053966E5}"/>
+                <a16:creationId xmlns:a16="http://schemas.microsoft.com/office/drawing/2014/main" id="{86C5A383-7C53-4135-952F-E3B7CD43824F}"/>
               </a:ext>
             </a:extLst>
           </p:cNvPr>
@@ -8913,7 +8921,7 @@
           <p:cNvPr id="13" name="">
             <a:extLst xmlns:a="http://schemas.openxmlformats.org/drawingml/2006/main">
               <a:ext uri="{FF2B5EF4-FFF2-40B4-BE49-F238E27FC236}">
-                <a16:creationId xmlns:a16="http://schemas.microsoft.com/office/drawing/2014/main" id="{DF79D60A-50D2-49C0-837F-094231470C0C}"/>
+                <a16:creationId xmlns:a16="http://schemas.microsoft.com/office/drawing/2014/main" id="{988442D0-D419-4EEF-BAB3-560F6B7D8C29}"/>
               </a:ext>
             </a:extLst>
           </p:cNvPr>
@@ -8968,7 +8976,7 @@
     </p:spTree>
     <p:extLst>
       <p:ext uri="{BB962C8B-B14F-4D97-AF65-F5344CB8AC3E}">
-        <p14:creationId xmlns:p14="http://schemas.microsoft.com/office/powerpoint/2010/main" val="794974414"/>
+        <p14:creationId xmlns:p14="http://schemas.microsoft.com/office/powerpoint/2010/main" val="142239016"/>
       </p:ext>
     </p:extLst>
   </p:cSld>
@@ -8999,7 +9007,7 @@
           <p:cNvPr id="6" name="">
             <a:extLst xmlns:a="http://schemas.openxmlformats.org/drawingml/2006/main">
               <a:ext uri="{FF2B5EF4-FFF2-40B4-BE49-F238E27FC236}">
-                <a16:creationId xmlns:a16="http://schemas.microsoft.com/office/drawing/2014/main" id="{4ABEC7EC-A55F-411C-BC50-B716384707E9}"/>
+                <a16:creationId xmlns:a16="http://schemas.microsoft.com/office/drawing/2014/main" id="{3662CC05-2F6F-4365-8506-7316E8A9DED0}"/>
               </a:ext>
             </a:extLst>
           </p:cNvPr>
@@ -9056,7 +9064,7 @@
           <p:cNvPr id="2" name="">
             <a:extLst xmlns:a="http://schemas.openxmlformats.org/drawingml/2006/main">
               <a:ext uri="{FF2B5EF4-FFF2-40B4-BE49-F238E27FC236}">
-                <a16:creationId xmlns:a16="http://schemas.microsoft.com/office/drawing/2014/main" id="{F7874856-13FC-4635-BD97-B4751405C9C4}"/>
+                <a16:creationId xmlns:a16="http://schemas.microsoft.com/office/drawing/2014/main" id="{B5CF65EC-3423-4943-B68D-DEA074392D2F}"/>
               </a:ext>
             </a:extLst>
           </p:cNvPr>
@@ -9113,7 +9121,7 @@
           <p:cNvPr id="3" name="">
             <a:extLst xmlns:a="http://schemas.openxmlformats.org/drawingml/2006/main">
               <a:ext uri="{FF2B5EF4-FFF2-40B4-BE49-F238E27FC236}">
-                <a16:creationId xmlns:a16="http://schemas.microsoft.com/office/drawing/2014/main" id="{35A8A6D7-7AA8-42AB-959E-435B4D837405}"/>
+                <a16:creationId xmlns:a16="http://schemas.microsoft.com/office/drawing/2014/main" id="{57D67D0F-9B00-4F07-92F0-CEC3DB0FAF63}"/>
               </a:ext>
             </a:extLst>
           </p:cNvPr>
@@ -9195,7 +9203,7 @@
                       <a:r>
                         <a:rPr sz="1575" b="1">
                           <a:solidFill>
-                            <a:srgbClr val="071411"/>
+                            <a:srgbClr val="5CFF67"/>
                           </a:solidFill>
                           <a:latin typeface="Helvetica Neue"/>
                           <a:ea typeface="Helvetica Neue"/>
@@ -9217,7 +9225,7 @@
                       <a:r>
                         <a:rPr sz="1575" b="1">
                           <a:solidFill>
-                            <a:srgbClr val="071411"/>
+                            <a:srgbClr val="5CFF67"/>
                           </a:solidFill>
                           <a:latin typeface="Helvetica Neue"/>
                           <a:ea typeface="Helvetica Neue"/>
@@ -9239,7 +9247,7 @@
                       <a:r>
                         <a:rPr sz="1575" b="1">
                           <a:solidFill>
-                            <a:srgbClr val="071411"/>
+                            <a:srgbClr val="5CFF67"/>
                           </a:solidFill>
                           <a:latin typeface="Helvetica Neue"/>
                           <a:ea typeface="Helvetica Neue"/>
@@ -9533,7 +9541,7 @@
           <p:cNvPr id="5" name="">
             <a:extLst xmlns:a="http://schemas.openxmlformats.org/drawingml/2006/main">
               <a:ext uri="{FF2B5EF4-FFF2-40B4-BE49-F238E27FC236}">
-                <a16:creationId xmlns:a16="http://schemas.microsoft.com/office/drawing/2014/main" id="{8538C1AC-05FA-4AEB-A94E-E7A73783F5EF}"/>
+                <a16:creationId xmlns:a16="http://schemas.microsoft.com/office/drawing/2014/main" id="{E2BB5993-0C59-4135-948C-A3A1EAFF8DBE}"/>
               </a:ext>
             </a:extLst>
           </p:cNvPr>
@@ -9588,7 +9596,7 @@
     </p:spTree>
     <p:extLst>
       <p:ext uri="{BB962C8B-B14F-4D97-AF65-F5344CB8AC3E}">
-        <p14:creationId xmlns:p14="http://schemas.microsoft.com/office/powerpoint/2010/main" val="1198384347"/>
+        <p14:creationId xmlns:p14="http://schemas.microsoft.com/office/powerpoint/2010/main" val="1149176540"/>
       </p:ext>
     </p:extLst>
   </p:cSld>
@@ -9619,7 +9627,7 @@
           <p:cNvPr id="15" name="">
             <a:extLst xmlns:a="http://schemas.openxmlformats.org/drawingml/2006/main">
               <a:ext uri="{FF2B5EF4-FFF2-40B4-BE49-F238E27FC236}">
-                <a16:creationId xmlns:a16="http://schemas.microsoft.com/office/drawing/2014/main" id="{FBB87FCF-0F74-4089-A0D1-6A738B6A2DE9}"/>
+                <a16:creationId xmlns:a16="http://schemas.microsoft.com/office/drawing/2014/main" id="{56AC8B91-3302-4E85-A48F-0ACA862E3EB2}"/>
               </a:ext>
             </a:extLst>
           </p:cNvPr>
@@ -9676,7 +9684,7 @@
           <p:cNvPr id="2" name="">
             <a:extLst xmlns:a="http://schemas.openxmlformats.org/drawingml/2006/main">
               <a:ext uri="{FF2B5EF4-FFF2-40B4-BE49-F238E27FC236}">
-                <a16:creationId xmlns:a16="http://schemas.microsoft.com/office/drawing/2014/main" id="{2581996B-2BC6-49B3-878B-7B9C82142203}"/>
+                <a16:creationId xmlns:a16="http://schemas.microsoft.com/office/drawing/2014/main" id="{F70A6539-D2C5-4533-BF15-94A0D2BC9AFE}"/>
               </a:ext>
             </a:extLst>
           </p:cNvPr>
@@ -9733,7 +9741,7 @@
           <p:cNvPr id="3" name="">
             <a:extLst xmlns:a="http://schemas.openxmlformats.org/drawingml/2006/main">
               <a:ext uri="{FF2B5EF4-FFF2-40B4-BE49-F238E27FC236}">
-                <a16:creationId xmlns:a16="http://schemas.microsoft.com/office/drawing/2014/main" id="{AF0E6728-1D54-4AD4-B5C2-E748635DA3EF}"/>
+                <a16:creationId xmlns:a16="http://schemas.microsoft.com/office/drawing/2014/main" id="{6F7DEE0C-61C4-4AEE-883B-59245150E2F8}"/>
               </a:ext>
             </a:extLst>
           </p:cNvPr>
@@ -9790,7 +9798,7 @@
           <p:cNvPr id="4" name="">
             <a:extLst xmlns:a="http://schemas.openxmlformats.org/drawingml/2006/main">
               <a:ext uri="{FF2B5EF4-FFF2-40B4-BE49-F238E27FC236}">
-                <a16:creationId xmlns:a16="http://schemas.microsoft.com/office/drawing/2014/main" id="{2193EB53-6F8C-45BF-A60F-058A95556AF5}"/>
+                <a16:creationId xmlns:a16="http://schemas.microsoft.com/office/drawing/2014/main" id="{3EA60653-5165-40A9-AE39-858EE02FF7E2}"/>
               </a:ext>
             </a:extLst>
           </p:cNvPr>
@@ -9807,6 +9815,7 @@
           <a:prstGeom xmlns:a="http://schemas.openxmlformats.org/drawingml/2006/main" prst="rect">
             <a:avLst/>
           </a:prstGeom>
+          <a:noFill xmlns:a="http://schemas.openxmlformats.org/drawingml/2006/main"/>
           <a:ln xmlns:a="http://schemas.openxmlformats.org/drawingml/2006/main" w="0">
             <a:noFill/>
           </a:ln>
@@ -9846,7 +9855,7 @@
           <p:cNvPr id="5" name="">
             <a:extLst xmlns:a="http://schemas.openxmlformats.org/drawingml/2006/main">
               <a:ext uri="{FF2B5EF4-FFF2-40B4-BE49-F238E27FC236}">
-                <a16:creationId xmlns:a16="http://schemas.microsoft.com/office/drawing/2014/main" id="{5D3431D3-D610-4194-A223-0EB3D2B25B18}"/>
+                <a16:creationId xmlns:a16="http://schemas.microsoft.com/office/drawing/2014/main" id="{82B692D9-61B5-4C91-B3E3-4EF2DA38C36F}"/>
               </a:ext>
             </a:extLst>
           </p:cNvPr>
@@ -9863,6 +9872,7 @@
           <a:prstGeom xmlns:a="http://schemas.openxmlformats.org/drawingml/2006/main" prst="rect">
             <a:avLst/>
           </a:prstGeom>
+          <a:noFill xmlns:a="http://schemas.openxmlformats.org/drawingml/2006/main"/>
           <a:ln xmlns:a="http://schemas.openxmlformats.org/drawingml/2006/main" w="0">
             <a:noFill/>
           </a:ln>
@@ -9902,7 +9912,7 @@
           <p:cNvPr id="6" name="">
             <a:extLst xmlns:a="http://schemas.openxmlformats.org/drawingml/2006/main">
               <a:ext uri="{FF2B5EF4-FFF2-40B4-BE49-F238E27FC236}">
-                <a16:creationId xmlns:a16="http://schemas.microsoft.com/office/drawing/2014/main" id="{4BB7A191-0046-416C-AEE4-6F56C73FFEE8}"/>
+                <a16:creationId xmlns:a16="http://schemas.microsoft.com/office/drawing/2014/main" id="{578B6D7E-B312-47E2-9FB1-C663AB25D9A6}"/>
               </a:ext>
             </a:extLst>
           </p:cNvPr>
@@ -9919,6 +9929,7 @@
           <a:prstGeom xmlns:a="http://schemas.openxmlformats.org/drawingml/2006/main" prst="rect">
             <a:avLst/>
           </a:prstGeom>
+          <a:noFill xmlns:a="http://schemas.openxmlformats.org/drawingml/2006/main"/>
           <a:ln xmlns:a="http://schemas.openxmlformats.org/drawingml/2006/main" w="0">
             <a:noFill/>
           </a:ln>
@@ -9932,7 +9943,7 @@
             <a:pPr>
               <a:defRPr sz="2025" b="1">
                 <a:solidFill>
-                  <a:srgbClr val="071411"/>
+                  <a:srgbClr val="5CFF67"/>
                 </a:solidFill>
                 <a:latin typeface="Helvetica Neue"/>
                 <a:ea typeface="Helvetica Neue"/>
@@ -9942,7 +9953,7 @@
             <a:r>
               <a:rPr sz="2025" b="1">
                 <a:solidFill>
-                  <a:srgbClr val="071411"/>
+                  <a:srgbClr val="5CFF67"/>
                 </a:solidFill>
                 <a:latin typeface="Helvetica Neue"/>
                 <a:ea typeface="Helvetica Neue"/>
@@ -9958,7 +9969,7 @@
           <p:cNvPr id="7" name="">
             <a:extLst xmlns:a="http://schemas.openxmlformats.org/drawingml/2006/main">
               <a:ext uri="{FF2B5EF4-FFF2-40B4-BE49-F238E27FC236}">
-                <a16:creationId xmlns:a16="http://schemas.microsoft.com/office/drawing/2014/main" id="{A4F0EDB8-9563-4A0D-93A7-8F40F7E0A601}"/>
+                <a16:creationId xmlns:a16="http://schemas.microsoft.com/office/drawing/2014/main" id="{33EBBA04-E59D-4509-BB89-2992E5186601}"/>
               </a:ext>
             </a:extLst>
           </p:cNvPr>
@@ -9975,6 +9986,7 @@
           <a:prstGeom xmlns:a="http://schemas.openxmlformats.org/drawingml/2006/main" prst="rect">
             <a:avLst/>
           </a:prstGeom>
+          <a:noFill xmlns:a="http://schemas.openxmlformats.org/drawingml/2006/main"/>
           <a:ln xmlns:a="http://schemas.openxmlformats.org/drawingml/2006/main" w="0">
             <a:noFill/>
           </a:ln>
@@ -10014,7 +10026,7 @@
           <p:cNvPr id="8" name="">
             <a:extLst xmlns:a="http://schemas.openxmlformats.org/drawingml/2006/main">
               <a:ext uri="{FF2B5EF4-FFF2-40B4-BE49-F238E27FC236}">
-                <a16:creationId xmlns:a16="http://schemas.microsoft.com/office/drawing/2014/main" id="{25DA8181-0A2E-471A-8DDF-5343DDB71EEE}"/>
+                <a16:creationId xmlns:a16="http://schemas.microsoft.com/office/drawing/2014/main" id="{52FE4950-1B52-45DC-82B5-9FF420A2E75B}"/>
               </a:ext>
             </a:extLst>
           </p:cNvPr>
@@ -10071,7 +10083,7 @@
           <p:cNvPr id="9" name="">
             <a:extLst xmlns:a="http://schemas.openxmlformats.org/drawingml/2006/main">
               <a:ext uri="{FF2B5EF4-FFF2-40B4-BE49-F238E27FC236}">
-                <a16:creationId xmlns:a16="http://schemas.microsoft.com/office/drawing/2014/main" id="{C1E77059-9571-4961-9237-D956308A184B}"/>
+                <a16:creationId xmlns:a16="http://schemas.microsoft.com/office/drawing/2014/main" id="{D838168A-6B3C-4899-BDE6-D5FDAF7BD2F6}"/>
               </a:ext>
             </a:extLst>
           </p:cNvPr>
@@ -10128,7 +10140,7 @@
           <p:cNvPr id="10" name="">
             <a:extLst xmlns:a="http://schemas.openxmlformats.org/drawingml/2006/main">
               <a:ext uri="{FF2B5EF4-FFF2-40B4-BE49-F238E27FC236}">
-                <a16:creationId xmlns:a16="http://schemas.microsoft.com/office/drawing/2014/main" id="{2F1FF2E8-11E2-4451-9F6D-4B140522B5D5}"/>
+                <a16:creationId xmlns:a16="http://schemas.microsoft.com/office/drawing/2014/main" id="{FCF45575-6D99-4ABA-85A7-7322A1B5E5D1}"/>
               </a:ext>
             </a:extLst>
           </p:cNvPr>
@@ -10185,7 +10197,7 @@
           <p:cNvPr id="11" name="">
             <a:extLst xmlns:a="http://schemas.openxmlformats.org/drawingml/2006/main">
               <a:ext uri="{FF2B5EF4-FFF2-40B4-BE49-F238E27FC236}">
-                <a16:creationId xmlns:a16="http://schemas.microsoft.com/office/drawing/2014/main" id="{50EF16B6-75DA-4866-8010-2B87CF9B2274}"/>
+                <a16:creationId xmlns:a16="http://schemas.microsoft.com/office/drawing/2014/main" id="{0A1C6153-2B9F-4ED0-877C-76D7B825CDC4}"/>
               </a:ext>
             </a:extLst>
           </p:cNvPr>
@@ -10242,7 +10254,7 @@
           <p:cNvPr id="12" name="">
             <a:extLst xmlns:a="http://schemas.openxmlformats.org/drawingml/2006/main">
               <a:ext uri="{FF2B5EF4-FFF2-40B4-BE49-F238E27FC236}">
-                <a16:creationId xmlns:a16="http://schemas.microsoft.com/office/drawing/2014/main" id="{4570E2C3-4DA9-4168-9E06-FCA2D8E8A870}"/>
+                <a16:creationId xmlns:a16="http://schemas.microsoft.com/office/drawing/2014/main" id="{41EED78D-C7B4-42B2-8547-4DA79D51965A}"/>
               </a:ext>
             </a:extLst>
           </p:cNvPr>
@@ -10299,7 +10311,7 @@
           <p:cNvPr id="13" name="">
             <a:extLst xmlns:a="http://schemas.openxmlformats.org/drawingml/2006/main">
               <a:ext uri="{FF2B5EF4-FFF2-40B4-BE49-F238E27FC236}">
-                <a16:creationId xmlns:a16="http://schemas.microsoft.com/office/drawing/2014/main" id="{3146CFD7-F2D3-4F03-B05B-2AC85EF5ACE8}"/>
+                <a16:creationId xmlns:a16="http://schemas.microsoft.com/office/drawing/2014/main" id="{001EFBE1-CADD-40D1-9B29-025D956BB3AB}"/>
               </a:ext>
             </a:extLst>
           </p:cNvPr>
@@ -10356,7 +10368,7 @@
           <p:cNvPr id="14" name="">
             <a:extLst xmlns:a="http://schemas.openxmlformats.org/drawingml/2006/main">
               <a:ext uri="{FF2B5EF4-FFF2-40B4-BE49-F238E27FC236}">
-                <a16:creationId xmlns:a16="http://schemas.microsoft.com/office/drawing/2014/main" id="{E36C2A50-781B-41D7-B7F1-824A4F6880AC}"/>
+                <a16:creationId xmlns:a16="http://schemas.microsoft.com/office/drawing/2014/main" id="{B3DF3A56-1FBB-416D-AC4E-87FB184CFFE1}"/>
               </a:ext>
             </a:extLst>
           </p:cNvPr>
@@ -10411,7 +10423,7 @@
     </p:spTree>
     <p:extLst>
       <p:ext uri="{BB962C8B-B14F-4D97-AF65-F5344CB8AC3E}">
-        <p14:creationId xmlns:p14="http://schemas.microsoft.com/office/powerpoint/2010/main" val="884985272"/>
+        <p14:creationId xmlns:p14="http://schemas.microsoft.com/office/powerpoint/2010/main" val="1307186435"/>
       </p:ext>
     </p:extLst>
   </p:cSld>

</xml_diff>